<commit_message>
Replace estimated school-to-school distances with Google Maps routes
Walking and driving distance/time for all 6 pairs (searched 2026-10-27),
screenshots kept in input/maps/.

Co-Authored-By: Claude Opus 5.5 <noreply@anthropic.com>
Claude-Session: https://claude.ai/code/session_01W71YS9cuG6jLhNCgQT7KJE
</commit_message>
<xml_diff>
--- a/output/若穂地区_住民説明会資料.pptx
+++ b/output/若穂地区_住民説明会資料.pptx
@@ -2321,7 +2321,7 @@
           <a:p>
             <a:r>
               <a:rPr lang="en-US" dirty="0"/>
-              <a:t>学校間の距離であり、各家庭からの通学距離ではないことを必ず口頭で伝える。距離は直線距離からの概算です。統合を検討する段階で、事務局が実際の通学路・スクールバスの経路で測り直す前提で示します。</a:t>
+              <a:t>学校間の距離であり、各家庭からの通学距離ではないことを必ず口頭で伝える。道のりと時間はGoogle マップの経路検索（2026年10月27日の夜、片方向）。徒歩は大人の速さ、車は夜の交通量での値で、朝の通学時間帯は長くなることがある。保科小へ向かう徒歩は約100mの上り（若穂中→保科小 上り102m、綿内小→保科小 上り113m、保科小→川田小 下り104m）。各家庭からの距離と子どもの歩く速さでの実測は、事務局に依頼する。</a:t>
             </a:r>
             <a:endParaRPr lang="en-US" dirty="0"/>
           </a:p>
@@ -16988,6 +16988,62 @@
           </a:p>
         </p:txBody>
       </p:sp>
+      <p:sp>
+        <p:nvSpPr>
+          <p:cNvPr id="39" name="Text 37"/>
+          <p:cNvSpPr txBox="1"/>
+          <p:nvPr/>
+        </p:nvSpPr>
+        <p:spPr>
+          <a:xfrm>
+            <a:off x="822960" y="2240280"/>
+            <a:ext cx="2560320" cy="502920"/>
+          </a:xfrm>
+          <a:prstGeom prst="rect">
+            <a:avLst/>
+          </a:prstGeom>
+          <a:noFill/>
+          <a:ln/>
+        </p:spPr>
+        <p:txBody>
+          <a:bodyPr wrap="square" lIns="0" tIns="0" rIns="0" bIns="0" rtlCol="0" anchor="t"/>
+          <a:lstStyle/>
+          <a:p>
+            <a:pPr indent="0" marL="0">
+              <a:buNone/>
+            </a:pPr>
+            <a:r>
+              <a:rPr lang="en-US" sz="1200" dirty="0">
+                <a:solidFill>
+                  <a:srgbClr val="56635D"/>
+                </a:solidFill>
+                <a:latin typeface="BIZ UDPゴシック" pitchFamily="34" charset="0"/>
+                <a:ea typeface="BIZ UDPゴシック" pitchFamily="34" charset="-122"/>
+                <a:cs typeface="BIZ UDPゴシック" pitchFamily="34" charset="-120"/>
+              </a:rPr>
+              <a:t>保科小は、ほかの3校より</a:t>
+            </a:r>
+            <a:endParaRPr lang="en-US" sz="1200" dirty="0"/>
+          </a:p>
+          <a:p>
+            <a:pPr indent="0" marL="0">
+              <a:buNone/>
+            </a:pPr>
+            <a:r>
+              <a:rPr lang="en-US" sz="1200" dirty="0">
+                <a:solidFill>
+                  <a:srgbClr val="56635D"/>
+                </a:solidFill>
+                <a:latin typeface="BIZ UDPゴシック" pitchFamily="34" charset="0"/>
+                <a:ea typeface="BIZ UDPゴシック" pitchFamily="34" charset="-122"/>
+                <a:cs typeface="BIZ UDPゴシック" pitchFamily="34" charset="-120"/>
+              </a:rPr>
+              <a:t>約100m高い所にあります</a:t>
+            </a:r>
+            <a:endParaRPr lang="en-US" sz="1200" dirty="0"/>
+          </a:p>
+        </p:txBody>
+      </p:sp>
       <p:graphicFrame>
         <p:nvGraphicFramePr>
           <p:cNvPr id="20" name="Table 0"/>
@@ -17013,13 +17069,13 @@
               <a:tblGrid>
                 <a:gridCol w="457200"/>
                 <a:gridCol w="1645920"/>
-                <a:gridCol w="594360"/>
-                <a:gridCol w="777240"/>
                 <a:gridCol w="822960"/>
-                <a:gridCol w="1005840"/>
+                <a:gridCol w="731520"/>
+                <a:gridCol w="822960"/>
+                <a:gridCol w="822960"/>
               </a:tblGrid>
-              <a:tr h="548640">
-                <a:tc>
+              <a:tr h="347472">
+                <a:tc rowSpan="2">
                   <a:txBody>
                     <a:bodyPr/>
                     <a:lstStyle/>
@@ -17087,7 +17143,7 @@
                     </a:solidFill>
                   </a:tcPr>
                 </a:tc>
-                <a:tc>
+                <a:tc rowSpan="2">
                   <a:txBody>
                     <a:bodyPr/>
                     <a:lstStyle/>
@@ -17155,6 +17211,156 @@
                     </a:solidFill>
                   </a:tcPr>
                 </a:tc>
+                <a:tc gridSpan="2">
+                  <a:txBody>
+                    <a:bodyPr/>
+                    <a:lstStyle/>
+                    <a:p>
+                      <a:pPr algn="ctr" indent="0" marL="0">
+                        <a:buNone/>
+                      </a:pPr>
+                      <a:r>
+                        <a:rPr lang="en-US" sz="1400" b="1" dirty="0">
+                          <a:solidFill>
+                            <a:srgbClr val="FFFFFF"/>
+                          </a:solidFill>
+                          <a:latin typeface="BIZ UDPゴシック" pitchFamily="34" charset="0"/>
+                          <a:ea typeface="BIZ UDPゴシック" pitchFamily="34" charset="-122"/>
+                          <a:cs typeface="BIZ UDPゴシック" pitchFamily="34" charset="-120"/>
+                        </a:rPr>
+                        <a:t>徒歩</a:t>
+                      </a:r>
+                      <a:endParaRPr lang="en-US" sz="1400" dirty="0">
+                        <a:latin typeface="BIZ UDPゴシック" charset="0"/>
+                        <a:ea typeface="BIZ UDPゴシック" charset="0"/>
+                        <a:cs typeface="BIZ UDPゴシック" charset="0"/>
+                      </a:endParaRPr>
+                    </a:p>
+                  </a:txBody>
+                  <a:tcPr marL="91440" marR="91440" marT="45720" marB="45720" anchor="ctr">
+                    <a:lnL w="12700" cap="flat" cmpd="sng" algn="ctr">
+                      <a:solidFill>
+                        <a:srgbClr val="D7DFDA"/>
+                      </a:solidFill>
+                      <a:prstDash val="solid"/>
+                      <a:round/>
+                      <a:headEnd type="none" w="med" len="med"/>
+                      <a:tailEnd type="none" w="med" len="med"/>
+                    </a:lnL>
+                    <a:lnR w="12700" cap="flat" cmpd="sng" algn="ctr">
+                      <a:solidFill>
+                        <a:srgbClr val="D7DFDA"/>
+                      </a:solidFill>
+                      <a:prstDash val="solid"/>
+                      <a:round/>
+                      <a:headEnd type="none" w="med" len="med"/>
+                      <a:tailEnd type="none" w="med" len="med"/>
+                    </a:lnR>
+                    <a:lnT w="12700" cap="flat" cmpd="sng" algn="ctr">
+                      <a:solidFill>
+                        <a:srgbClr val="D7DFDA"/>
+                      </a:solidFill>
+                      <a:prstDash val="solid"/>
+                      <a:round/>
+                      <a:headEnd type="none" w="med" len="med"/>
+                      <a:tailEnd type="none" w="med" len="med"/>
+                    </a:lnT>
+                    <a:lnB w="12700" cap="flat" cmpd="sng" algn="ctr">
+                      <a:solidFill>
+                        <a:srgbClr val="D7DFDA"/>
+                      </a:solidFill>
+                      <a:prstDash val="solid"/>
+                      <a:round/>
+                      <a:headEnd type="none" w="med" len="med"/>
+                      <a:tailEnd type="none" w="med" len="med"/>
+                    </a:lnB>
+                    <a:solidFill>
+                      <a:srgbClr val="1D4636"/>
+                    </a:solidFill>
+                  </a:tcPr>
+                </a:tc>
+                <a:tc hMerge="1">
+                  <a:tcPr/>
+                </a:tc>
+                <a:tc gridSpan="2">
+                  <a:txBody>
+                    <a:bodyPr/>
+                    <a:lstStyle/>
+                    <a:p>
+                      <a:pPr algn="ctr" indent="0" marL="0">
+                        <a:buNone/>
+                      </a:pPr>
+                      <a:r>
+                        <a:rPr lang="en-US" sz="1400" b="1" dirty="0">
+                          <a:solidFill>
+                            <a:srgbClr val="FFFFFF"/>
+                          </a:solidFill>
+                          <a:latin typeface="BIZ UDPゴシック" pitchFamily="34" charset="0"/>
+                          <a:ea typeface="BIZ UDPゴシック" pitchFamily="34" charset="-122"/>
+                          <a:cs typeface="BIZ UDPゴシック" pitchFamily="34" charset="-120"/>
+                        </a:rPr>
+                        <a:t>車</a:t>
+                      </a:r>
+                      <a:endParaRPr lang="en-US" sz="1400" dirty="0">
+                        <a:latin typeface="BIZ UDPゴシック" charset="0"/>
+                        <a:ea typeface="BIZ UDPゴシック" charset="0"/>
+                        <a:cs typeface="BIZ UDPゴシック" charset="0"/>
+                      </a:endParaRPr>
+                    </a:p>
+                  </a:txBody>
+                  <a:tcPr marL="91440" marR="91440" marT="45720" marB="45720" anchor="ctr">
+                    <a:lnL w="12700" cap="flat" cmpd="sng" algn="ctr">
+                      <a:solidFill>
+                        <a:srgbClr val="D7DFDA"/>
+                      </a:solidFill>
+                      <a:prstDash val="solid"/>
+                      <a:round/>
+                      <a:headEnd type="none" w="med" len="med"/>
+                      <a:tailEnd type="none" w="med" len="med"/>
+                    </a:lnL>
+                    <a:lnR w="12700" cap="flat" cmpd="sng" algn="ctr">
+                      <a:solidFill>
+                        <a:srgbClr val="D7DFDA"/>
+                      </a:solidFill>
+                      <a:prstDash val="solid"/>
+                      <a:round/>
+                      <a:headEnd type="none" w="med" len="med"/>
+                      <a:tailEnd type="none" w="med" len="med"/>
+                    </a:lnR>
+                    <a:lnT w="12700" cap="flat" cmpd="sng" algn="ctr">
+                      <a:solidFill>
+                        <a:srgbClr val="D7DFDA"/>
+                      </a:solidFill>
+                      <a:prstDash val="solid"/>
+                      <a:round/>
+                      <a:headEnd type="none" w="med" len="med"/>
+                      <a:tailEnd type="none" w="med" len="med"/>
+                    </a:lnT>
+                    <a:lnB w="12700" cap="flat" cmpd="sng" algn="ctr">
+                      <a:solidFill>
+                        <a:srgbClr val="D7DFDA"/>
+                      </a:solidFill>
+                      <a:prstDash val="solid"/>
+                      <a:round/>
+                      <a:headEnd type="none" w="med" len="med"/>
+                      <a:tailEnd type="none" w="med" len="med"/>
+                    </a:lnB>
+                    <a:solidFill>
+                      <a:srgbClr val="1D4636"/>
+                    </a:solidFill>
+                  </a:tcPr>
+                </a:tc>
+                <a:tc hMerge="1">
+                  <a:tcPr/>
+                </a:tc>
+              </a:tr>
+              <a:tr h="347472">
+                <a:tc vMerge="1">
+                  <a:tcPr/>
+                </a:tc>
+                <a:tc vMerge="1">
+                  <a:tcPr/>
+                </a:tc>
                 <a:tc>
                   <a:txBody>
                     <a:bodyPr/>
@@ -17172,7 +17378,7 @@
                           <a:ea typeface="BIZ UDPゴシック" pitchFamily="34" charset="-122"/>
                           <a:cs typeface="BIZ UDPゴシック" pitchFamily="34" charset="-120"/>
                         </a:rPr>
-                        <a:t>直線</a:t>
+                        <a:t>道のり</a:t>
                       </a:r>
                       <a:endParaRPr lang="en-US" sz="1400" dirty="0">
                         <a:latin typeface="BIZ UDPゴシック" charset="0"/>
@@ -17180,6 +17386,53 @@
                         <a:cs typeface="BIZ UDPゴシック" charset="0"/>
                       </a:endParaRPr>
                     </a:p>
+                  </a:txBody>
+                  <a:tcPr marL="91440" marR="91440" marT="45720" marB="45720" anchor="ctr">
+                    <a:lnL w="12700" cap="flat" cmpd="sng" algn="ctr">
+                      <a:solidFill>
+                        <a:srgbClr val="D7DFDA"/>
+                      </a:solidFill>
+                      <a:prstDash val="solid"/>
+                      <a:round/>
+                      <a:headEnd type="none" w="med" len="med"/>
+                      <a:tailEnd type="none" w="med" len="med"/>
+                    </a:lnL>
+                    <a:lnR w="12700" cap="flat" cmpd="sng" algn="ctr">
+                      <a:solidFill>
+                        <a:srgbClr val="D7DFDA"/>
+                      </a:solidFill>
+                      <a:prstDash val="solid"/>
+                      <a:round/>
+                      <a:headEnd type="none" w="med" len="med"/>
+                      <a:tailEnd type="none" w="med" len="med"/>
+                    </a:lnR>
+                    <a:lnT w="12700" cap="flat" cmpd="sng" algn="ctr">
+                      <a:solidFill>
+                        <a:srgbClr val="D7DFDA"/>
+                      </a:solidFill>
+                      <a:prstDash val="solid"/>
+                      <a:round/>
+                      <a:headEnd type="none" w="med" len="med"/>
+                      <a:tailEnd type="none" w="med" len="med"/>
+                    </a:lnT>
+                    <a:lnB w="12700" cap="flat" cmpd="sng" algn="ctr">
+                      <a:solidFill>
+                        <a:srgbClr val="D7DFDA"/>
+                      </a:solidFill>
+                      <a:prstDash val="solid"/>
+                      <a:round/>
+                      <a:headEnd type="none" w="med" len="med"/>
+                      <a:tailEnd type="none" w="med" len="med"/>
+                    </a:lnB>
+                    <a:solidFill>
+                      <a:srgbClr val="1D4636"/>
+                    </a:solidFill>
+                  </a:tcPr>
+                </a:tc>
+                <a:tc>
+                  <a:txBody>
+                    <a:bodyPr/>
+                    <a:lstStyle/>
                     <a:p>
                       <a:pPr algn="ctr" indent="0" marL="0">
                         <a:buNone/>
@@ -17193,7 +17446,7 @@
                           <a:ea typeface="BIZ UDPゴシック" pitchFamily="34" charset="-122"/>
                           <a:cs typeface="BIZ UDPゴシック" pitchFamily="34" charset="-120"/>
                         </a:rPr>
-                        <a:t>(km)</a:t>
+                        <a:t>時間</a:t>
                       </a:r>
                       <a:endParaRPr lang="en-US" sz="1400" dirty="0">
                         <a:latin typeface="BIZ UDPゴシック" charset="0"/>
@@ -17269,27 +17522,6 @@
                         <a:cs typeface="BIZ UDPゴシック" charset="0"/>
                       </a:endParaRPr>
                     </a:p>
-                    <a:p>
-                      <a:pPr algn="ctr" indent="0" marL="0">
-                        <a:buNone/>
-                      </a:pPr>
-                      <a:r>
-                        <a:rPr lang="en-US" sz="1400" b="1" dirty="0">
-                          <a:solidFill>
-                            <a:srgbClr val="FFFFFF"/>
-                          </a:solidFill>
-                          <a:latin typeface="BIZ UDPゴシック" pitchFamily="34" charset="0"/>
-                          <a:ea typeface="BIZ UDPゴシック" pitchFamily="34" charset="-122"/>
-                          <a:cs typeface="BIZ UDPゴシック" pitchFamily="34" charset="-120"/>
-                        </a:rPr>
-                        <a:t>(km)</a:t>
-                      </a:r>
-                      <a:endParaRPr lang="en-US" sz="1400" dirty="0">
-                        <a:latin typeface="BIZ UDPゴシック" charset="0"/>
-                        <a:ea typeface="BIZ UDPゴシック" charset="0"/>
-                        <a:cs typeface="BIZ UDPゴシック" charset="0"/>
-                      </a:endParaRPr>
-                    </a:p>
                   </a:txBody>
                   <a:tcPr marL="91440" marR="91440" marT="45720" marB="45720" anchor="ctr">
                     <a:lnL w="12700" cap="flat" cmpd="sng" algn="ctr">
@@ -17350,7 +17582,7 @@
                           <a:ea typeface="BIZ UDPゴシック" pitchFamily="34" charset="-122"/>
                           <a:cs typeface="BIZ UDPゴシック" pitchFamily="34" charset="-120"/>
                         </a:rPr>
-                        <a:t>車</a:t>
+                        <a:t>時間</a:t>
                       </a:r>
                       <a:endParaRPr lang="en-US" sz="1400" dirty="0">
                         <a:latin typeface="BIZ UDPゴシック" charset="0"/>
@@ -17401,76 +17633,8 @@
                     </a:solidFill>
                   </a:tcPr>
                 </a:tc>
-                <a:tc>
-                  <a:txBody>
-                    <a:bodyPr/>
-                    <a:lstStyle/>
-                    <a:p>
-                      <a:pPr algn="ctr" indent="0" marL="0">
-                        <a:buNone/>
-                      </a:pPr>
-                      <a:r>
-                        <a:rPr lang="en-US" sz="1400" b="1" dirty="0">
-                          <a:solidFill>
-                            <a:srgbClr val="FFFFFF"/>
-                          </a:solidFill>
-                          <a:latin typeface="BIZ UDPゴシック" pitchFamily="34" charset="0"/>
-                          <a:ea typeface="BIZ UDPゴシック" pitchFamily="34" charset="-122"/>
-                          <a:cs typeface="BIZ UDPゴシック" pitchFamily="34" charset="-120"/>
-                        </a:rPr>
-                        <a:t>徒歩</a:t>
-                      </a:r>
-                      <a:endParaRPr lang="en-US" sz="1400" dirty="0">
-                        <a:latin typeface="BIZ UDPゴシック" charset="0"/>
-                        <a:ea typeface="BIZ UDPゴシック" charset="0"/>
-                        <a:cs typeface="BIZ UDPゴシック" charset="0"/>
-                      </a:endParaRPr>
-                    </a:p>
-                  </a:txBody>
-                  <a:tcPr marL="91440" marR="91440" marT="45720" marB="45720" anchor="ctr">
-                    <a:lnL w="12700" cap="flat" cmpd="sng" algn="ctr">
-                      <a:solidFill>
-                        <a:srgbClr val="D7DFDA"/>
-                      </a:solidFill>
-                      <a:prstDash val="solid"/>
-                      <a:round/>
-                      <a:headEnd type="none" w="med" len="med"/>
-                      <a:tailEnd type="none" w="med" len="med"/>
-                    </a:lnL>
-                    <a:lnR w="12700" cap="flat" cmpd="sng" algn="ctr">
-                      <a:solidFill>
-                        <a:srgbClr val="D7DFDA"/>
-                      </a:solidFill>
-                      <a:prstDash val="solid"/>
-                      <a:round/>
-                      <a:headEnd type="none" w="med" len="med"/>
-                      <a:tailEnd type="none" w="med" len="med"/>
-                    </a:lnR>
-                    <a:lnT w="12700" cap="flat" cmpd="sng" algn="ctr">
-                      <a:solidFill>
-                        <a:srgbClr val="D7DFDA"/>
-                      </a:solidFill>
-                      <a:prstDash val="solid"/>
-                      <a:round/>
-                      <a:headEnd type="none" w="med" len="med"/>
-                      <a:tailEnd type="none" w="med" len="med"/>
-                    </a:lnT>
-                    <a:lnB w="12700" cap="flat" cmpd="sng" algn="ctr">
-                      <a:solidFill>
-                        <a:srgbClr val="D7DFDA"/>
-                      </a:solidFill>
-                      <a:prstDash val="solid"/>
-                      <a:round/>
-                      <a:headEnd type="none" w="med" len="med"/>
-                      <a:tailEnd type="none" w="med" len="med"/>
-                    </a:lnB>
-                    <a:solidFill>
-                      <a:srgbClr val="1D4636"/>
-                    </a:solidFill>
-                  </a:tcPr>
-                </a:tc>
               </a:tr>
-              <a:tr h="438912">
+              <a:tr h="420624">
                 <a:tc>
                   <a:txBody>
                     <a:bodyPr/>
@@ -17624,7 +17788,75 @@
                           <a:ea typeface="BIZ UDPゴシック" pitchFamily="34" charset="-122"/>
                           <a:cs typeface="BIZ UDPゴシック" pitchFamily="34" charset="-120"/>
                         </a:rPr>
-                        <a:t>2.8</a:t>
+                        <a:t>3.2km</a:t>
+                      </a:r>
+                      <a:endParaRPr lang="en-US" sz="1400" dirty="0">
+                        <a:latin typeface="BIZ UDPゴシック" charset="0"/>
+                        <a:ea typeface="BIZ UDPゴシック" charset="0"/>
+                        <a:cs typeface="BIZ UDPゴシック" charset="0"/>
+                      </a:endParaRPr>
+                    </a:p>
+                  </a:txBody>
+                  <a:tcPr marL="91440" marR="91440" marT="45720" marB="45720" anchor="ctr">
+                    <a:lnL w="12700" cap="flat" cmpd="sng" algn="ctr">
+                      <a:solidFill>
+                        <a:srgbClr val="D7DFDA"/>
+                      </a:solidFill>
+                      <a:prstDash val="solid"/>
+                      <a:round/>
+                      <a:headEnd type="none" w="med" len="med"/>
+                      <a:tailEnd type="none" w="med" len="med"/>
+                    </a:lnL>
+                    <a:lnR w="12700" cap="flat" cmpd="sng" algn="ctr">
+                      <a:solidFill>
+                        <a:srgbClr val="D7DFDA"/>
+                      </a:solidFill>
+                      <a:prstDash val="solid"/>
+                      <a:round/>
+                      <a:headEnd type="none" w="med" len="med"/>
+                      <a:tailEnd type="none" w="med" len="med"/>
+                    </a:lnR>
+                    <a:lnT w="12700" cap="flat" cmpd="sng" algn="ctr">
+                      <a:solidFill>
+                        <a:srgbClr val="D7DFDA"/>
+                      </a:solidFill>
+                      <a:prstDash val="solid"/>
+                      <a:round/>
+                      <a:headEnd type="none" w="med" len="med"/>
+                      <a:tailEnd type="none" w="med" len="med"/>
+                    </a:lnT>
+                    <a:lnB w="12700" cap="flat" cmpd="sng" algn="ctr">
+                      <a:solidFill>
+                        <a:srgbClr val="D7DFDA"/>
+                      </a:solidFill>
+                      <a:prstDash val="solid"/>
+                      <a:round/>
+                      <a:headEnd type="none" w="med" len="med"/>
+                      <a:tailEnd type="none" w="med" len="med"/>
+                    </a:lnB>
+                    <a:solidFill>
+                      <a:srgbClr val="F4F7F5"/>
+                    </a:solidFill>
+                  </a:tcPr>
+                </a:tc>
+                <a:tc>
+                  <a:txBody>
+                    <a:bodyPr/>
+                    <a:lstStyle/>
+                    <a:p>
+                      <a:pPr algn="ctr" indent="0" marL="0">
+                        <a:buNone/>
+                      </a:pPr>
+                      <a:r>
+                        <a:rPr lang="en-US" sz="1400" b="1" dirty="0">
+                          <a:solidFill>
+                            <a:srgbClr val="1E2A26"/>
+                          </a:solidFill>
+                          <a:latin typeface="BIZ UDPゴシック" pitchFamily="34" charset="0"/>
+                          <a:ea typeface="BIZ UDPゴシック" pitchFamily="34" charset="-122"/>
+                          <a:cs typeface="BIZ UDPゴシック" pitchFamily="34" charset="-120"/>
+                        </a:rPr>
+                        <a:t>44分</a:t>
                       </a:r>
                       <a:endParaRPr lang="en-US" sz="1400" dirty="0">
                         <a:latin typeface="BIZ UDPゴシック" charset="0"/>
@@ -17692,7 +17924,7 @@
                           <a:ea typeface="BIZ UDPゴシック" pitchFamily="34" charset="-122"/>
                           <a:cs typeface="BIZ UDPゴシック" pitchFamily="34" charset="-120"/>
                         </a:rPr>
-                        <a:t>約3.6</a:t>
+                        <a:t>3.5km</a:t>
                       </a:r>
                       <a:endParaRPr lang="en-US" sz="1400" dirty="0">
                         <a:latin typeface="BIZ UDPゴシック" charset="0"/>
@@ -17760,7 +17992,7 @@
                           <a:ea typeface="BIZ UDPゴシック" pitchFamily="34" charset="-122"/>
                           <a:cs typeface="BIZ UDPゴシック" pitchFamily="34" charset="-120"/>
                         </a:rPr>
-                        <a:t>約9分</a:t>
+                        <a:t>6分</a:t>
                       </a:r>
                       <a:endParaRPr lang="en-US" sz="1400" dirty="0">
                         <a:latin typeface="BIZ UDPゴシック" charset="0"/>
@@ -17811,76 +18043,8 @@
                     </a:solidFill>
                   </a:tcPr>
                 </a:tc>
-                <a:tc>
-                  <a:txBody>
-                    <a:bodyPr/>
-                    <a:lstStyle/>
-                    <a:p>
-                      <a:pPr algn="ctr" indent="0" marL="0">
-                        <a:buNone/>
-                      </a:pPr>
-                      <a:r>
-                        <a:rPr lang="en-US" sz="1400" dirty="0">
-                          <a:solidFill>
-                            <a:srgbClr val="1E2A26"/>
-                          </a:solidFill>
-                          <a:latin typeface="BIZ UDPゴシック" pitchFamily="34" charset="0"/>
-                          <a:ea typeface="BIZ UDPゴシック" pitchFamily="34" charset="-122"/>
-                          <a:cs typeface="BIZ UDPゴシック" pitchFamily="34" charset="-120"/>
-                        </a:rPr>
-                        <a:t>約55分</a:t>
-                      </a:r>
-                      <a:endParaRPr lang="en-US" sz="1400" dirty="0">
-                        <a:latin typeface="BIZ UDPゴシック" charset="0"/>
-                        <a:ea typeface="BIZ UDPゴシック" charset="0"/>
-                        <a:cs typeface="BIZ UDPゴシック" charset="0"/>
-                      </a:endParaRPr>
-                    </a:p>
-                  </a:txBody>
-                  <a:tcPr marL="91440" marR="91440" marT="45720" marB="45720" anchor="ctr">
-                    <a:lnL w="12700" cap="flat" cmpd="sng" algn="ctr">
-                      <a:solidFill>
-                        <a:srgbClr val="D7DFDA"/>
-                      </a:solidFill>
-                      <a:prstDash val="solid"/>
-                      <a:round/>
-                      <a:headEnd type="none" w="med" len="med"/>
-                      <a:tailEnd type="none" w="med" len="med"/>
-                    </a:lnL>
-                    <a:lnR w="12700" cap="flat" cmpd="sng" algn="ctr">
-                      <a:solidFill>
-                        <a:srgbClr val="D7DFDA"/>
-                      </a:solidFill>
-                      <a:prstDash val="solid"/>
-                      <a:round/>
-                      <a:headEnd type="none" w="med" len="med"/>
-                      <a:tailEnd type="none" w="med" len="med"/>
-                    </a:lnR>
-                    <a:lnT w="12700" cap="flat" cmpd="sng" algn="ctr">
-                      <a:solidFill>
-                        <a:srgbClr val="D7DFDA"/>
-                      </a:solidFill>
-                      <a:prstDash val="solid"/>
-                      <a:round/>
-                      <a:headEnd type="none" w="med" len="med"/>
-                      <a:tailEnd type="none" w="med" len="med"/>
-                    </a:lnT>
-                    <a:lnB w="12700" cap="flat" cmpd="sng" algn="ctr">
-                      <a:solidFill>
-                        <a:srgbClr val="D7DFDA"/>
-                      </a:solidFill>
-                      <a:prstDash val="solid"/>
-                      <a:round/>
-                      <a:headEnd type="none" w="med" len="med"/>
-                      <a:tailEnd type="none" w="med" len="med"/>
-                    </a:lnB>
-                    <a:solidFill>
-                      <a:srgbClr val="F4F7F5"/>
-                    </a:solidFill>
-                  </a:tcPr>
-                </a:tc>
               </a:tr>
-              <a:tr h="438912">
+              <a:tr h="420624">
                 <a:tc>
                   <a:txBody>
                     <a:bodyPr/>
@@ -18034,7 +18198,75 @@
                           <a:ea typeface="BIZ UDPゴシック" pitchFamily="34" charset="-122"/>
                           <a:cs typeface="BIZ UDPゴシック" pitchFamily="34" charset="-120"/>
                         </a:rPr>
-                        <a:t>2.8</a:t>
+                        <a:t>3.0km</a:t>
+                      </a:r>
+                      <a:endParaRPr lang="en-US" sz="1400" dirty="0">
+                        <a:latin typeface="BIZ UDPゴシック" charset="0"/>
+                        <a:ea typeface="BIZ UDPゴシック" charset="0"/>
+                        <a:cs typeface="BIZ UDPゴシック" charset="0"/>
+                      </a:endParaRPr>
+                    </a:p>
+                  </a:txBody>
+                  <a:tcPr marL="91440" marR="91440" marT="45720" marB="45720" anchor="ctr">
+                    <a:lnL w="12700" cap="flat" cmpd="sng" algn="ctr">
+                      <a:solidFill>
+                        <a:srgbClr val="D7DFDA"/>
+                      </a:solidFill>
+                      <a:prstDash val="solid"/>
+                      <a:round/>
+                      <a:headEnd type="none" w="med" len="med"/>
+                      <a:tailEnd type="none" w="med" len="med"/>
+                    </a:lnL>
+                    <a:lnR w="12700" cap="flat" cmpd="sng" algn="ctr">
+                      <a:solidFill>
+                        <a:srgbClr val="D7DFDA"/>
+                      </a:solidFill>
+                      <a:prstDash val="solid"/>
+                      <a:round/>
+                      <a:headEnd type="none" w="med" len="med"/>
+                      <a:tailEnd type="none" w="med" len="med"/>
+                    </a:lnR>
+                    <a:lnT w="12700" cap="flat" cmpd="sng" algn="ctr">
+                      <a:solidFill>
+                        <a:srgbClr val="D7DFDA"/>
+                      </a:solidFill>
+                      <a:prstDash val="solid"/>
+                      <a:round/>
+                      <a:headEnd type="none" w="med" len="med"/>
+                      <a:tailEnd type="none" w="med" len="med"/>
+                    </a:lnT>
+                    <a:lnB w="12700" cap="flat" cmpd="sng" algn="ctr">
+                      <a:solidFill>
+                        <a:srgbClr val="D7DFDA"/>
+                      </a:solidFill>
+                      <a:prstDash val="solid"/>
+                      <a:round/>
+                      <a:headEnd type="none" w="med" len="med"/>
+                      <a:tailEnd type="none" w="med" len="med"/>
+                    </a:lnB>
+                    <a:solidFill>
+                      <a:srgbClr val="FFFFFF"/>
+                    </a:solidFill>
+                  </a:tcPr>
+                </a:tc>
+                <a:tc>
+                  <a:txBody>
+                    <a:bodyPr/>
+                    <a:lstStyle/>
+                    <a:p>
+                      <a:pPr algn="ctr" indent="0" marL="0">
+                        <a:buNone/>
+                      </a:pPr>
+                      <a:r>
+                        <a:rPr lang="en-US" sz="1400" b="1" dirty="0">
+                          <a:solidFill>
+                            <a:srgbClr val="1E2A26"/>
+                          </a:solidFill>
+                          <a:latin typeface="BIZ UDPゴシック" pitchFamily="34" charset="0"/>
+                          <a:ea typeface="BIZ UDPゴシック" pitchFamily="34" charset="-122"/>
+                          <a:cs typeface="BIZ UDPゴシック" pitchFamily="34" charset="-120"/>
+                        </a:rPr>
+                        <a:t>36分</a:t>
                       </a:r>
                       <a:endParaRPr lang="en-US" sz="1400" dirty="0">
                         <a:latin typeface="BIZ UDPゴシック" charset="0"/>
@@ -18102,7 +18334,7 @@
                           <a:ea typeface="BIZ UDPゴシック" pitchFamily="34" charset="-122"/>
                           <a:cs typeface="BIZ UDPゴシック" pitchFamily="34" charset="-120"/>
                         </a:rPr>
-                        <a:t>約3.7</a:t>
+                        <a:t>3.2km</a:t>
                       </a:r>
                       <a:endParaRPr lang="en-US" sz="1400" dirty="0">
                         <a:latin typeface="BIZ UDPゴシック" charset="0"/>
@@ -18170,7 +18402,7 @@
                           <a:ea typeface="BIZ UDPゴシック" pitchFamily="34" charset="-122"/>
                           <a:cs typeface="BIZ UDPゴシック" pitchFamily="34" charset="-120"/>
                         </a:rPr>
-                        <a:t>約9分</a:t>
+                        <a:t>5分</a:t>
                       </a:r>
                       <a:endParaRPr lang="en-US" sz="1400" dirty="0">
                         <a:latin typeface="BIZ UDPゴシック" charset="0"/>
@@ -18221,76 +18453,8 @@
                     </a:solidFill>
                   </a:tcPr>
                 </a:tc>
-                <a:tc>
-                  <a:txBody>
-                    <a:bodyPr/>
-                    <a:lstStyle/>
-                    <a:p>
-                      <a:pPr algn="ctr" indent="0" marL="0">
-                        <a:buNone/>
-                      </a:pPr>
-                      <a:r>
-                        <a:rPr lang="en-US" sz="1400" dirty="0">
-                          <a:solidFill>
-                            <a:srgbClr val="1E2A26"/>
-                          </a:solidFill>
-                          <a:latin typeface="BIZ UDPゴシック" pitchFamily="34" charset="0"/>
-                          <a:ea typeface="BIZ UDPゴシック" pitchFamily="34" charset="-122"/>
-                          <a:cs typeface="BIZ UDPゴシック" pitchFamily="34" charset="-120"/>
-                        </a:rPr>
-                        <a:t>約55分</a:t>
-                      </a:r>
-                      <a:endParaRPr lang="en-US" sz="1400" dirty="0">
-                        <a:latin typeface="BIZ UDPゴシック" charset="0"/>
-                        <a:ea typeface="BIZ UDPゴシック" charset="0"/>
-                        <a:cs typeface="BIZ UDPゴシック" charset="0"/>
-                      </a:endParaRPr>
-                    </a:p>
-                  </a:txBody>
-                  <a:tcPr marL="91440" marR="91440" marT="45720" marB="45720" anchor="ctr">
-                    <a:lnL w="12700" cap="flat" cmpd="sng" algn="ctr">
-                      <a:solidFill>
-                        <a:srgbClr val="D7DFDA"/>
-                      </a:solidFill>
-                      <a:prstDash val="solid"/>
-                      <a:round/>
-                      <a:headEnd type="none" w="med" len="med"/>
-                      <a:tailEnd type="none" w="med" len="med"/>
-                    </a:lnL>
-                    <a:lnR w="12700" cap="flat" cmpd="sng" algn="ctr">
-                      <a:solidFill>
-                        <a:srgbClr val="D7DFDA"/>
-                      </a:solidFill>
-                      <a:prstDash val="solid"/>
-                      <a:round/>
-                      <a:headEnd type="none" w="med" len="med"/>
-                      <a:tailEnd type="none" w="med" len="med"/>
-                    </a:lnR>
-                    <a:lnT w="12700" cap="flat" cmpd="sng" algn="ctr">
-                      <a:solidFill>
-                        <a:srgbClr val="D7DFDA"/>
-                      </a:solidFill>
-                      <a:prstDash val="solid"/>
-                      <a:round/>
-                      <a:headEnd type="none" w="med" len="med"/>
-                      <a:tailEnd type="none" w="med" len="med"/>
-                    </a:lnT>
-                    <a:lnB w="12700" cap="flat" cmpd="sng" algn="ctr">
-                      <a:solidFill>
-                        <a:srgbClr val="D7DFDA"/>
-                      </a:solidFill>
-                      <a:prstDash val="solid"/>
-                      <a:round/>
-                      <a:headEnd type="none" w="med" len="med"/>
-                      <a:tailEnd type="none" w="med" len="med"/>
-                    </a:lnB>
-                    <a:solidFill>
-                      <a:srgbClr val="FFFFFF"/>
-                    </a:solidFill>
-                  </a:tcPr>
-                </a:tc>
               </a:tr>
-              <a:tr h="438912">
+              <a:tr h="420624">
                 <a:tc>
                   <a:txBody>
                     <a:bodyPr/>
@@ -18444,7 +18608,75 @@
                           <a:ea typeface="BIZ UDPゴシック" pitchFamily="34" charset="-122"/>
                           <a:cs typeface="BIZ UDPゴシック" pitchFamily="34" charset="-120"/>
                         </a:rPr>
-                        <a:t>3.9</a:t>
+                        <a:t>4.9km</a:t>
+                      </a:r>
+                      <a:endParaRPr lang="en-US" sz="1400" dirty="0">
+                        <a:latin typeface="BIZ UDPゴシック" charset="0"/>
+                        <a:ea typeface="BIZ UDPゴシック" charset="0"/>
+                        <a:cs typeface="BIZ UDPゴシック" charset="0"/>
+                      </a:endParaRPr>
+                    </a:p>
+                  </a:txBody>
+                  <a:tcPr marL="91440" marR="91440" marT="45720" marB="45720" anchor="ctr">
+                    <a:lnL w="12700" cap="flat" cmpd="sng" algn="ctr">
+                      <a:solidFill>
+                        <a:srgbClr val="D7DFDA"/>
+                      </a:solidFill>
+                      <a:prstDash val="solid"/>
+                      <a:round/>
+                      <a:headEnd type="none" w="med" len="med"/>
+                      <a:tailEnd type="none" w="med" len="med"/>
+                    </a:lnL>
+                    <a:lnR w="12700" cap="flat" cmpd="sng" algn="ctr">
+                      <a:solidFill>
+                        <a:srgbClr val="D7DFDA"/>
+                      </a:solidFill>
+                      <a:prstDash val="solid"/>
+                      <a:round/>
+                      <a:headEnd type="none" w="med" len="med"/>
+                      <a:tailEnd type="none" w="med" len="med"/>
+                    </a:lnR>
+                    <a:lnT w="12700" cap="flat" cmpd="sng" algn="ctr">
+                      <a:solidFill>
+                        <a:srgbClr val="D7DFDA"/>
+                      </a:solidFill>
+                      <a:prstDash val="solid"/>
+                      <a:round/>
+                      <a:headEnd type="none" w="med" len="med"/>
+                      <a:tailEnd type="none" w="med" len="med"/>
+                    </a:lnT>
+                    <a:lnB w="12700" cap="flat" cmpd="sng" algn="ctr">
+                      <a:solidFill>
+                        <a:srgbClr val="D7DFDA"/>
+                      </a:solidFill>
+                      <a:prstDash val="solid"/>
+                      <a:round/>
+                      <a:headEnd type="none" w="med" len="med"/>
+                      <a:tailEnd type="none" w="med" len="med"/>
+                    </a:lnB>
+                    <a:solidFill>
+                      <a:srgbClr val="F4F7F5"/>
+                    </a:solidFill>
+                  </a:tcPr>
+                </a:tc>
+                <a:tc>
+                  <a:txBody>
+                    <a:bodyPr/>
+                    <a:lstStyle/>
+                    <a:p>
+                      <a:pPr algn="ctr" indent="0" marL="0">
+                        <a:buNone/>
+                      </a:pPr>
+                      <a:r>
+                        <a:rPr lang="en-US" sz="1400" b="1" dirty="0">
+                          <a:solidFill>
+                            <a:srgbClr val="1E2A26"/>
+                          </a:solidFill>
+                          <a:latin typeface="BIZ UDPゴシック" pitchFamily="34" charset="0"/>
+                          <a:ea typeface="BIZ UDPゴシック" pitchFamily="34" charset="-122"/>
+                          <a:cs typeface="BIZ UDPゴシック" pitchFamily="34" charset="-120"/>
+                        </a:rPr>
+                        <a:t>72分</a:t>
                       </a:r>
                       <a:endParaRPr lang="en-US" sz="1400" dirty="0">
                         <a:latin typeface="BIZ UDPゴシック" charset="0"/>
@@ -18512,7 +18744,7 @@
                           <a:ea typeface="BIZ UDPゴシック" pitchFamily="34" charset="-122"/>
                           <a:cs typeface="BIZ UDPゴシック" pitchFamily="34" charset="-120"/>
                         </a:rPr>
-                        <a:t>約5.1</a:t>
+                        <a:t>5.6km</a:t>
                       </a:r>
                       <a:endParaRPr lang="en-US" sz="1400" dirty="0">
                         <a:latin typeface="BIZ UDPゴシック" charset="0"/>
@@ -18580,7 +18812,7 @@
                           <a:ea typeface="BIZ UDPゴシック" pitchFamily="34" charset="-122"/>
                           <a:cs typeface="BIZ UDPゴシック" pitchFamily="34" charset="-120"/>
                         </a:rPr>
-                        <a:t>約12分</a:t>
+                        <a:t>8分</a:t>
                       </a:r>
                       <a:endParaRPr lang="en-US" sz="1400" dirty="0">
                         <a:latin typeface="BIZ UDPゴシック" charset="0"/>
@@ -18631,76 +18863,8 @@
                     </a:solidFill>
                   </a:tcPr>
                 </a:tc>
-                <a:tc>
-                  <a:txBody>
-                    <a:bodyPr/>
-                    <a:lstStyle/>
-                    <a:p>
-                      <a:pPr algn="ctr" indent="0" marL="0">
-                        <a:buNone/>
-                      </a:pPr>
-                      <a:r>
-                        <a:rPr lang="en-US" sz="1400" dirty="0">
-                          <a:solidFill>
-                            <a:srgbClr val="1E2A26"/>
-                          </a:solidFill>
-                          <a:latin typeface="BIZ UDPゴシック" pitchFamily="34" charset="0"/>
-                          <a:ea typeface="BIZ UDPゴシック" pitchFamily="34" charset="-122"/>
-                          <a:cs typeface="BIZ UDPゴシック" pitchFamily="34" charset="-120"/>
-                        </a:rPr>
-                        <a:t>約75分</a:t>
-                      </a:r>
-                      <a:endParaRPr lang="en-US" sz="1400" dirty="0">
-                        <a:latin typeface="BIZ UDPゴシック" charset="0"/>
-                        <a:ea typeface="BIZ UDPゴシック" charset="0"/>
-                        <a:cs typeface="BIZ UDPゴシック" charset="0"/>
-                      </a:endParaRPr>
-                    </a:p>
-                  </a:txBody>
-                  <a:tcPr marL="91440" marR="91440" marT="45720" marB="45720" anchor="ctr">
-                    <a:lnL w="12700" cap="flat" cmpd="sng" algn="ctr">
-                      <a:solidFill>
-                        <a:srgbClr val="D7DFDA"/>
-                      </a:solidFill>
-                      <a:prstDash val="solid"/>
-                      <a:round/>
-                      <a:headEnd type="none" w="med" len="med"/>
-                      <a:tailEnd type="none" w="med" len="med"/>
-                    </a:lnL>
-                    <a:lnR w="12700" cap="flat" cmpd="sng" algn="ctr">
-                      <a:solidFill>
-                        <a:srgbClr val="D7DFDA"/>
-                      </a:solidFill>
-                      <a:prstDash val="solid"/>
-                      <a:round/>
-                      <a:headEnd type="none" w="med" len="med"/>
-                      <a:tailEnd type="none" w="med" len="med"/>
-                    </a:lnR>
-                    <a:lnT w="12700" cap="flat" cmpd="sng" algn="ctr">
-                      <a:solidFill>
-                        <a:srgbClr val="D7DFDA"/>
-                      </a:solidFill>
-                      <a:prstDash val="solid"/>
-                      <a:round/>
-                      <a:headEnd type="none" w="med" len="med"/>
-                      <a:tailEnd type="none" w="med" len="med"/>
-                    </a:lnT>
-                    <a:lnB w="12700" cap="flat" cmpd="sng" algn="ctr">
-                      <a:solidFill>
-                        <a:srgbClr val="D7DFDA"/>
-                      </a:solidFill>
-                      <a:prstDash val="solid"/>
-                      <a:round/>
-                      <a:headEnd type="none" w="med" len="med"/>
-                      <a:tailEnd type="none" w="med" len="med"/>
-                    </a:lnB>
-                    <a:solidFill>
-                      <a:srgbClr val="F4F7F5"/>
-                    </a:solidFill>
-                  </a:tcPr>
-                </a:tc>
               </a:tr>
-              <a:tr h="438912">
+              <a:tr h="420624">
                 <a:tc>
                   <a:txBody>
                     <a:bodyPr/>
@@ -18854,7 +19018,75 @@
                           <a:ea typeface="BIZ UDPゴシック" pitchFamily="34" charset="-122"/>
                           <a:cs typeface="BIZ UDPゴシック" pitchFamily="34" charset="-120"/>
                         </a:rPr>
-                        <a:t>2.2</a:t>
+                        <a:t>2.5km</a:t>
+                      </a:r>
+                      <a:endParaRPr lang="en-US" sz="1400" dirty="0">
+                        <a:latin typeface="BIZ UDPゴシック" charset="0"/>
+                        <a:ea typeface="BIZ UDPゴシック" charset="0"/>
+                        <a:cs typeface="BIZ UDPゴシック" charset="0"/>
+                      </a:endParaRPr>
+                    </a:p>
+                  </a:txBody>
+                  <a:tcPr marL="91440" marR="91440" marT="45720" marB="45720" anchor="ctr">
+                    <a:lnL w="12700" cap="flat" cmpd="sng" algn="ctr">
+                      <a:solidFill>
+                        <a:srgbClr val="D7DFDA"/>
+                      </a:solidFill>
+                      <a:prstDash val="solid"/>
+                      <a:round/>
+                      <a:headEnd type="none" w="med" len="med"/>
+                      <a:tailEnd type="none" w="med" len="med"/>
+                    </a:lnL>
+                    <a:lnR w="12700" cap="flat" cmpd="sng" algn="ctr">
+                      <a:solidFill>
+                        <a:srgbClr val="D7DFDA"/>
+                      </a:solidFill>
+                      <a:prstDash val="solid"/>
+                      <a:round/>
+                      <a:headEnd type="none" w="med" len="med"/>
+                      <a:tailEnd type="none" w="med" len="med"/>
+                    </a:lnR>
+                    <a:lnT w="12700" cap="flat" cmpd="sng" algn="ctr">
+                      <a:solidFill>
+                        <a:srgbClr val="D7DFDA"/>
+                      </a:solidFill>
+                      <a:prstDash val="solid"/>
+                      <a:round/>
+                      <a:headEnd type="none" w="med" len="med"/>
+                      <a:tailEnd type="none" w="med" len="med"/>
+                    </a:lnT>
+                    <a:lnB w="12700" cap="flat" cmpd="sng" algn="ctr">
+                      <a:solidFill>
+                        <a:srgbClr val="D7DFDA"/>
+                      </a:solidFill>
+                      <a:prstDash val="solid"/>
+                      <a:round/>
+                      <a:headEnd type="none" w="med" len="med"/>
+                      <a:tailEnd type="none" w="med" len="med"/>
+                    </a:lnB>
+                    <a:solidFill>
+                      <a:srgbClr val="FFFFFF"/>
+                    </a:solidFill>
+                  </a:tcPr>
+                </a:tc>
+                <a:tc>
+                  <a:txBody>
+                    <a:bodyPr/>
+                    <a:lstStyle/>
+                    <a:p>
+                      <a:pPr algn="ctr" indent="0" marL="0">
+                        <a:buNone/>
+                      </a:pPr>
+                      <a:r>
+                        <a:rPr lang="en-US" sz="1400" b="1" dirty="0">
+                          <a:solidFill>
+                            <a:srgbClr val="1E2A26"/>
+                          </a:solidFill>
+                          <a:latin typeface="BIZ UDPゴシック" pitchFamily="34" charset="0"/>
+                          <a:ea typeface="BIZ UDPゴシック" pitchFamily="34" charset="-122"/>
+                          <a:cs typeface="BIZ UDPゴシック" pitchFamily="34" charset="-120"/>
+                        </a:rPr>
+                        <a:t>33分</a:t>
                       </a:r>
                       <a:endParaRPr lang="en-US" sz="1400" dirty="0">
                         <a:latin typeface="BIZ UDPゴシック" charset="0"/>
@@ -18922,7 +19154,7 @@
                           <a:ea typeface="BIZ UDPゴシック" pitchFamily="34" charset="-122"/>
                           <a:cs typeface="BIZ UDPゴシック" pitchFamily="34" charset="-120"/>
                         </a:rPr>
-                        <a:t>約2.9</a:t>
+                        <a:t>2.9km</a:t>
                       </a:r>
                       <a:endParaRPr lang="en-US" sz="1400" dirty="0">
                         <a:latin typeface="BIZ UDPゴシック" charset="0"/>
@@ -18990,7 +19222,7 @@
                           <a:ea typeface="BIZ UDPゴシック" pitchFamily="34" charset="-122"/>
                           <a:cs typeface="BIZ UDPゴシック" pitchFamily="34" charset="-120"/>
                         </a:rPr>
-                        <a:t>約7分</a:t>
+                        <a:t>5分</a:t>
                       </a:r>
                       <a:endParaRPr lang="en-US" sz="1400" dirty="0">
                         <a:latin typeface="BIZ UDPゴシック" charset="0"/>
@@ -19041,76 +19273,8 @@
                     </a:solidFill>
                   </a:tcPr>
                 </a:tc>
-                <a:tc>
-                  <a:txBody>
-                    <a:bodyPr/>
-                    <a:lstStyle/>
-                    <a:p>
-                      <a:pPr algn="ctr" indent="0" marL="0">
-                        <a:buNone/>
-                      </a:pPr>
-                      <a:r>
-                        <a:rPr lang="en-US" sz="1400" dirty="0">
-                          <a:solidFill>
-                            <a:srgbClr val="1E2A26"/>
-                          </a:solidFill>
-                          <a:latin typeface="BIZ UDPゴシック" pitchFamily="34" charset="0"/>
-                          <a:ea typeface="BIZ UDPゴシック" pitchFamily="34" charset="-122"/>
-                          <a:cs typeface="BIZ UDPゴシック" pitchFamily="34" charset="-120"/>
-                        </a:rPr>
-                        <a:t>約45分</a:t>
-                      </a:r>
-                      <a:endParaRPr lang="en-US" sz="1400" dirty="0">
-                        <a:latin typeface="BIZ UDPゴシック" charset="0"/>
-                        <a:ea typeface="BIZ UDPゴシック" charset="0"/>
-                        <a:cs typeface="BIZ UDPゴシック" charset="0"/>
-                      </a:endParaRPr>
-                    </a:p>
-                  </a:txBody>
-                  <a:tcPr marL="91440" marR="91440" marT="45720" marB="45720" anchor="ctr">
-                    <a:lnL w="12700" cap="flat" cmpd="sng" algn="ctr">
-                      <a:solidFill>
-                        <a:srgbClr val="D7DFDA"/>
-                      </a:solidFill>
-                      <a:prstDash val="solid"/>
-                      <a:round/>
-                      <a:headEnd type="none" w="med" len="med"/>
-                      <a:tailEnd type="none" w="med" len="med"/>
-                    </a:lnL>
-                    <a:lnR w="12700" cap="flat" cmpd="sng" algn="ctr">
-                      <a:solidFill>
-                        <a:srgbClr val="D7DFDA"/>
-                      </a:solidFill>
-                      <a:prstDash val="solid"/>
-                      <a:round/>
-                      <a:headEnd type="none" w="med" len="med"/>
-                      <a:tailEnd type="none" w="med" len="med"/>
-                    </a:lnR>
-                    <a:lnT w="12700" cap="flat" cmpd="sng" algn="ctr">
-                      <a:solidFill>
-                        <a:srgbClr val="D7DFDA"/>
-                      </a:solidFill>
-                      <a:prstDash val="solid"/>
-                      <a:round/>
-                      <a:headEnd type="none" w="med" len="med"/>
-                      <a:tailEnd type="none" w="med" len="med"/>
-                    </a:lnT>
-                    <a:lnB w="12700" cap="flat" cmpd="sng" algn="ctr">
-                      <a:solidFill>
-                        <a:srgbClr val="D7DFDA"/>
-                      </a:solidFill>
-                      <a:prstDash val="solid"/>
-                      <a:round/>
-                      <a:headEnd type="none" w="med" len="med"/>
-                      <a:tailEnd type="none" w="med" len="med"/>
-                    </a:lnB>
-                    <a:solidFill>
-                      <a:srgbClr val="FFFFFF"/>
-                    </a:solidFill>
-                  </a:tcPr>
-                </a:tc>
               </a:tr>
-              <a:tr h="438912">
+              <a:tr h="420624">
                 <a:tc>
                   <a:txBody>
                     <a:bodyPr/>
@@ -19264,7 +19428,75 @@
                           <a:ea typeface="BIZ UDPゴシック" pitchFamily="34" charset="-122"/>
                           <a:cs typeface="BIZ UDPゴシック" pitchFamily="34" charset="-120"/>
                         </a:rPr>
-                        <a:t>0.9</a:t>
+                        <a:t>1.1km</a:t>
+                      </a:r>
+                      <a:endParaRPr lang="en-US" sz="1400" dirty="0">
+                        <a:latin typeface="BIZ UDPゴシック" charset="0"/>
+                        <a:ea typeface="BIZ UDPゴシック" charset="0"/>
+                        <a:cs typeface="BIZ UDPゴシック" charset="0"/>
+                      </a:endParaRPr>
+                    </a:p>
+                  </a:txBody>
+                  <a:tcPr marL="91440" marR="91440" marT="45720" marB="45720" anchor="ctr">
+                    <a:lnL w="12700" cap="flat" cmpd="sng" algn="ctr">
+                      <a:solidFill>
+                        <a:srgbClr val="D7DFDA"/>
+                      </a:solidFill>
+                      <a:prstDash val="solid"/>
+                      <a:round/>
+                      <a:headEnd type="none" w="med" len="med"/>
+                      <a:tailEnd type="none" w="med" len="med"/>
+                    </a:lnL>
+                    <a:lnR w="12700" cap="flat" cmpd="sng" algn="ctr">
+                      <a:solidFill>
+                        <a:srgbClr val="D7DFDA"/>
+                      </a:solidFill>
+                      <a:prstDash val="solid"/>
+                      <a:round/>
+                      <a:headEnd type="none" w="med" len="med"/>
+                      <a:tailEnd type="none" w="med" len="med"/>
+                    </a:lnR>
+                    <a:lnT w="12700" cap="flat" cmpd="sng" algn="ctr">
+                      <a:solidFill>
+                        <a:srgbClr val="D7DFDA"/>
+                      </a:solidFill>
+                      <a:prstDash val="solid"/>
+                      <a:round/>
+                      <a:headEnd type="none" w="med" len="med"/>
+                      <a:tailEnd type="none" w="med" len="med"/>
+                    </a:lnT>
+                    <a:lnB w="12700" cap="flat" cmpd="sng" algn="ctr">
+                      <a:solidFill>
+                        <a:srgbClr val="D7DFDA"/>
+                      </a:solidFill>
+                      <a:prstDash val="solid"/>
+                      <a:round/>
+                      <a:headEnd type="none" w="med" len="med"/>
+                      <a:tailEnd type="none" w="med" len="med"/>
+                    </a:lnB>
+                    <a:solidFill>
+                      <a:srgbClr val="F4F7F5"/>
+                    </a:solidFill>
+                  </a:tcPr>
+                </a:tc>
+                <a:tc>
+                  <a:txBody>
+                    <a:bodyPr/>
+                    <a:lstStyle/>
+                    <a:p>
+                      <a:pPr algn="ctr" indent="0" marL="0">
+                        <a:buNone/>
+                      </a:pPr>
+                      <a:r>
+                        <a:rPr lang="en-US" sz="1400" b="1" dirty="0">
+                          <a:solidFill>
+                            <a:srgbClr val="1E2A26"/>
+                          </a:solidFill>
+                          <a:latin typeface="BIZ UDPゴシック" pitchFamily="34" charset="0"/>
+                          <a:ea typeface="BIZ UDPゴシック" pitchFamily="34" charset="-122"/>
+                          <a:cs typeface="BIZ UDPゴシック" pitchFamily="34" charset="-120"/>
+                        </a:rPr>
+                        <a:t>16分</a:t>
                       </a:r>
                       <a:endParaRPr lang="en-US" sz="1400" dirty="0">
                         <a:latin typeface="BIZ UDPゴシック" charset="0"/>
@@ -19332,7 +19564,7 @@
                           <a:ea typeface="BIZ UDPゴシック" pitchFamily="34" charset="-122"/>
                           <a:cs typeface="BIZ UDPゴシック" pitchFamily="34" charset="-120"/>
                         </a:rPr>
-                        <a:t>約1.1</a:t>
+                        <a:t>1.2km</a:t>
                       </a:r>
                       <a:endParaRPr lang="en-US" sz="1400" dirty="0">
                         <a:latin typeface="BIZ UDPゴシック" charset="0"/>
@@ -19400,7 +19632,7 @@
                           <a:ea typeface="BIZ UDPゴシック" pitchFamily="34" charset="-122"/>
                           <a:cs typeface="BIZ UDPゴシック" pitchFamily="34" charset="-120"/>
                         </a:rPr>
-                        <a:t>約3分</a:t>
+                        <a:t>3分</a:t>
                       </a:r>
                       <a:endParaRPr lang="en-US" sz="1400" dirty="0">
                         <a:latin typeface="BIZ UDPゴシック" charset="0"/>
@@ -19451,76 +19683,8 @@
                     </a:solidFill>
                   </a:tcPr>
                 </a:tc>
-                <a:tc>
-                  <a:txBody>
-                    <a:bodyPr/>
-                    <a:lstStyle/>
-                    <a:p>
-                      <a:pPr algn="ctr" indent="0" marL="0">
-                        <a:buNone/>
-                      </a:pPr>
-                      <a:r>
-                        <a:rPr lang="en-US" sz="1400" dirty="0">
-                          <a:solidFill>
-                            <a:srgbClr val="1E2A26"/>
-                          </a:solidFill>
-                          <a:latin typeface="BIZ UDPゴシック" pitchFamily="34" charset="0"/>
-                          <a:ea typeface="BIZ UDPゴシック" pitchFamily="34" charset="-122"/>
-                          <a:cs typeface="BIZ UDPゴシック" pitchFamily="34" charset="-120"/>
-                        </a:rPr>
-                        <a:t>約15分</a:t>
-                      </a:r>
-                      <a:endParaRPr lang="en-US" sz="1400" dirty="0">
-                        <a:latin typeface="BIZ UDPゴシック" charset="0"/>
-                        <a:ea typeface="BIZ UDPゴシック" charset="0"/>
-                        <a:cs typeface="BIZ UDPゴシック" charset="0"/>
-                      </a:endParaRPr>
-                    </a:p>
-                  </a:txBody>
-                  <a:tcPr marL="91440" marR="91440" marT="45720" marB="45720" anchor="ctr">
-                    <a:lnL w="12700" cap="flat" cmpd="sng" algn="ctr">
-                      <a:solidFill>
-                        <a:srgbClr val="D7DFDA"/>
-                      </a:solidFill>
-                      <a:prstDash val="solid"/>
-                      <a:round/>
-                      <a:headEnd type="none" w="med" len="med"/>
-                      <a:tailEnd type="none" w="med" len="med"/>
-                    </a:lnL>
-                    <a:lnR w="12700" cap="flat" cmpd="sng" algn="ctr">
-                      <a:solidFill>
-                        <a:srgbClr val="D7DFDA"/>
-                      </a:solidFill>
-                      <a:prstDash val="solid"/>
-                      <a:round/>
-                      <a:headEnd type="none" w="med" len="med"/>
-                      <a:tailEnd type="none" w="med" len="med"/>
-                    </a:lnR>
-                    <a:lnT w="12700" cap="flat" cmpd="sng" algn="ctr">
-                      <a:solidFill>
-                        <a:srgbClr val="D7DFDA"/>
-                      </a:solidFill>
-                      <a:prstDash val="solid"/>
-                      <a:round/>
-                      <a:headEnd type="none" w="med" len="med"/>
-                      <a:tailEnd type="none" w="med" len="med"/>
-                    </a:lnT>
-                    <a:lnB w="12700" cap="flat" cmpd="sng" algn="ctr">
-                      <a:solidFill>
-                        <a:srgbClr val="D7DFDA"/>
-                      </a:solidFill>
-                      <a:prstDash val="solid"/>
-                      <a:round/>
-                      <a:headEnd type="none" w="med" len="med"/>
-                      <a:tailEnd type="none" w="med" len="med"/>
-                    </a:lnB>
-                    <a:solidFill>
-                      <a:srgbClr val="F4F7F5"/>
-                    </a:solidFill>
-                  </a:tcPr>
-                </a:tc>
               </a:tr>
-              <a:tr h="438912">
+              <a:tr h="420624">
                 <a:tc>
                   <a:txBody>
                     <a:bodyPr/>
@@ -19674,7 +19838,75 @@
                           <a:ea typeface="BIZ UDPゴシック" pitchFamily="34" charset="-122"/>
                           <a:cs typeface="BIZ UDPゴシック" pitchFamily="34" charset="-120"/>
                         </a:rPr>
-                        <a:t>2.3</a:t>
+                        <a:t>2.5km</a:t>
+                      </a:r>
+                      <a:endParaRPr lang="en-US" sz="1400" dirty="0">
+                        <a:latin typeface="BIZ UDPゴシック" charset="0"/>
+                        <a:ea typeface="BIZ UDPゴシック" charset="0"/>
+                        <a:cs typeface="BIZ UDPゴシック" charset="0"/>
+                      </a:endParaRPr>
+                    </a:p>
+                  </a:txBody>
+                  <a:tcPr marL="91440" marR="91440" marT="45720" marB="45720" anchor="ctr">
+                    <a:lnL w="12700" cap="flat" cmpd="sng" algn="ctr">
+                      <a:solidFill>
+                        <a:srgbClr val="D7DFDA"/>
+                      </a:solidFill>
+                      <a:prstDash val="solid"/>
+                      <a:round/>
+                      <a:headEnd type="none" w="med" len="med"/>
+                      <a:tailEnd type="none" w="med" len="med"/>
+                    </a:lnL>
+                    <a:lnR w="12700" cap="flat" cmpd="sng" algn="ctr">
+                      <a:solidFill>
+                        <a:srgbClr val="D7DFDA"/>
+                      </a:solidFill>
+                      <a:prstDash val="solid"/>
+                      <a:round/>
+                      <a:headEnd type="none" w="med" len="med"/>
+                      <a:tailEnd type="none" w="med" len="med"/>
+                    </a:lnR>
+                    <a:lnT w="12700" cap="flat" cmpd="sng" algn="ctr">
+                      <a:solidFill>
+                        <a:srgbClr val="D7DFDA"/>
+                      </a:solidFill>
+                      <a:prstDash val="solid"/>
+                      <a:round/>
+                      <a:headEnd type="none" w="med" len="med"/>
+                      <a:tailEnd type="none" w="med" len="med"/>
+                    </a:lnT>
+                    <a:lnB w="12700" cap="flat" cmpd="sng" algn="ctr">
+                      <a:solidFill>
+                        <a:srgbClr val="D7DFDA"/>
+                      </a:solidFill>
+                      <a:prstDash val="solid"/>
+                      <a:round/>
+                      <a:headEnd type="none" w="med" len="med"/>
+                      <a:tailEnd type="none" w="med" len="med"/>
+                    </a:lnB>
+                    <a:solidFill>
+                      <a:srgbClr val="FFFFFF"/>
+                    </a:solidFill>
+                  </a:tcPr>
+                </a:tc>
+                <a:tc>
+                  <a:txBody>
+                    <a:bodyPr/>
+                    <a:lstStyle/>
+                    <a:p>
+                      <a:pPr algn="ctr" indent="0" marL="0">
+                        <a:buNone/>
+                      </a:pPr>
+                      <a:r>
+                        <a:rPr lang="en-US" sz="1400" b="1" dirty="0">
+                          <a:solidFill>
+                            <a:srgbClr val="1E2A26"/>
+                          </a:solidFill>
+                          <a:latin typeface="BIZ UDPゴシック" pitchFamily="34" charset="0"/>
+                          <a:ea typeface="BIZ UDPゴシック" pitchFamily="34" charset="-122"/>
+                          <a:cs typeface="BIZ UDPゴシック" pitchFamily="34" charset="-120"/>
+                        </a:rPr>
+                        <a:t>39分</a:t>
                       </a:r>
                       <a:endParaRPr lang="en-US" sz="1400" dirty="0">
                         <a:latin typeface="BIZ UDPゴシック" charset="0"/>
@@ -19742,7 +19974,7 @@
                           <a:ea typeface="BIZ UDPゴシック" pitchFamily="34" charset="-122"/>
                           <a:cs typeface="BIZ UDPゴシック" pitchFamily="34" charset="-120"/>
                         </a:rPr>
-                        <a:t>約3.0</a:t>
+                        <a:t>2.5km</a:t>
                       </a:r>
                       <a:endParaRPr lang="en-US" sz="1400" dirty="0">
                         <a:latin typeface="BIZ UDPゴシック" charset="0"/>
@@ -19810,75 +20042,7 @@
                           <a:ea typeface="BIZ UDPゴシック" pitchFamily="34" charset="-122"/>
                           <a:cs typeface="BIZ UDPゴシック" pitchFamily="34" charset="-120"/>
                         </a:rPr>
-                        <a:t>約7分</a:t>
-                      </a:r>
-                      <a:endParaRPr lang="en-US" sz="1400" dirty="0">
-                        <a:latin typeface="BIZ UDPゴシック" charset="0"/>
-                        <a:ea typeface="BIZ UDPゴシック" charset="0"/>
-                        <a:cs typeface="BIZ UDPゴシック" charset="0"/>
-                      </a:endParaRPr>
-                    </a:p>
-                  </a:txBody>
-                  <a:tcPr marL="91440" marR="91440" marT="45720" marB="45720" anchor="ctr">
-                    <a:lnL w="12700" cap="flat" cmpd="sng" algn="ctr">
-                      <a:solidFill>
-                        <a:srgbClr val="D7DFDA"/>
-                      </a:solidFill>
-                      <a:prstDash val="solid"/>
-                      <a:round/>
-                      <a:headEnd type="none" w="med" len="med"/>
-                      <a:tailEnd type="none" w="med" len="med"/>
-                    </a:lnL>
-                    <a:lnR w="12700" cap="flat" cmpd="sng" algn="ctr">
-                      <a:solidFill>
-                        <a:srgbClr val="D7DFDA"/>
-                      </a:solidFill>
-                      <a:prstDash val="solid"/>
-                      <a:round/>
-                      <a:headEnd type="none" w="med" len="med"/>
-                      <a:tailEnd type="none" w="med" len="med"/>
-                    </a:lnR>
-                    <a:lnT w="12700" cap="flat" cmpd="sng" algn="ctr">
-                      <a:solidFill>
-                        <a:srgbClr val="D7DFDA"/>
-                      </a:solidFill>
-                      <a:prstDash val="solid"/>
-                      <a:round/>
-                      <a:headEnd type="none" w="med" len="med"/>
-                      <a:tailEnd type="none" w="med" len="med"/>
-                    </a:lnT>
-                    <a:lnB w="12700" cap="flat" cmpd="sng" algn="ctr">
-                      <a:solidFill>
-                        <a:srgbClr val="D7DFDA"/>
-                      </a:solidFill>
-                      <a:prstDash val="solid"/>
-                      <a:round/>
-                      <a:headEnd type="none" w="med" len="med"/>
-                      <a:tailEnd type="none" w="med" len="med"/>
-                    </a:lnB>
-                    <a:solidFill>
-                      <a:srgbClr val="FFFFFF"/>
-                    </a:solidFill>
-                  </a:tcPr>
-                </a:tc>
-                <a:tc>
-                  <a:txBody>
-                    <a:bodyPr/>
-                    <a:lstStyle/>
-                    <a:p>
-                      <a:pPr algn="ctr" indent="0" marL="0">
-                        <a:buNone/>
-                      </a:pPr>
-                      <a:r>
-                        <a:rPr lang="en-US" sz="1400" dirty="0">
-                          <a:solidFill>
-                            <a:srgbClr val="1E2A26"/>
-                          </a:solidFill>
-                          <a:latin typeface="BIZ UDPゴシック" pitchFamily="34" charset="0"/>
-                          <a:ea typeface="BIZ UDPゴシック" pitchFamily="34" charset="-122"/>
-                          <a:cs typeface="BIZ UDPゴシック" pitchFamily="34" charset="-120"/>
-                        </a:rPr>
-                        <a:t>約45分</a:t>
+                        <a:t>4分</a:t>
                       </a:r>
                       <a:endParaRPr lang="en-US" sz="1400" dirty="0">
                         <a:latin typeface="BIZ UDPゴシック" charset="0"/>
@@ -19936,13 +20100,13 @@
       </p:graphicFrame>
       <p:sp>
         <p:nvSpPr>
-          <p:cNvPr id="40" name="Shape 37"/>
+          <p:cNvPr id="41" name="Shape 38"/>
           <p:cNvSpPr/>
           <p:nvPr/>
         </p:nvSpPr>
         <p:spPr>
           <a:xfrm>
-            <a:off x="6309360" y="4828032"/>
+            <a:off x="6309360" y="4800600"/>
             <a:ext cx="5303520" cy="621792"/>
           </a:xfrm>
           <a:prstGeom prst="roundRect">
@@ -19958,13 +20122,13 @@
       </p:sp>
       <p:sp>
         <p:nvSpPr>
-          <p:cNvPr id="41" name="Text 38"/>
+          <p:cNvPr id="42" name="Text 39"/>
           <p:cNvSpPr txBox="1"/>
           <p:nvPr/>
         </p:nvSpPr>
         <p:spPr>
           <a:xfrm>
-            <a:off x="6492240" y="4828032"/>
+            <a:off x="6492240" y="4800600"/>
             <a:ext cx="4937760" cy="621792"/>
           </a:xfrm>
           <a:prstGeom prst="rect">
@@ -19997,13 +20161,13 @@
       </p:sp>
       <p:sp>
         <p:nvSpPr>
-          <p:cNvPr id="42" name="Shape 39"/>
+          <p:cNvPr id="43" name="Shape 40"/>
           <p:cNvSpPr/>
           <p:nvPr/>
         </p:nvSpPr>
         <p:spPr>
           <a:xfrm>
-            <a:off x="6309360" y="5504688"/>
+            <a:off x="6309360" y="5486400"/>
             <a:ext cx="5303520" cy="566928"/>
           </a:xfrm>
           <a:prstGeom prst="roundRect">
@@ -20019,13 +20183,13 @@
       </p:sp>
       <p:sp>
         <p:nvSpPr>
-          <p:cNvPr id="43" name="Text 40"/>
+          <p:cNvPr id="44" name="Text 41"/>
           <p:cNvSpPr txBox="1"/>
           <p:nvPr/>
         </p:nvSpPr>
         <p:spPr>
           <a:xfrm>
-            <a:off x="6492240" y="5504688"/>
+            <a:off x="6492240" y="5486400"/>
             <a:ext cx="4937760" cy="566928"/>
           </a:xfrm>
           <a:prstGeom prst="rect">
@@ -20050,7 +20214,7 @@
                 <a:ea typeface="BIZ UDPゴシック" pitchFamily="34" charset="-122"/>
                 <a:cs typeface="BIZ UDPゴシック" pitchFamily="34" charset="-120"/>
               </a:rPr>
-              <a:t>学校と学校の距離で、子どもの通学距離ではありません。道のりは直線×1.3、車は時速25km・徒歩は時速4kmで概算。</a:t>
+              <a:t>学校と学校の距離で、子どもの通学距離ではありません。徒歩は大人の速さの目安で、子どもはもっとかかります。</a:t>
             </a:r>
             <a:endParaRPr lang="en-US" sz="1200" dirty="0"/>
           </a:p>
@@ -20058,7 +20222,7 @@
       </p:sp>
       <p:sp>
         <p:nvSpPr>
-          <p:cNvPr id="44" name="Text 41"/>
+          <p:cNvPr id="45" name="Text 42"/>
           <p:cNvSpPr txBox="1"/>
           <p:nvPr/>
         </p:nvSpPr>
@@ -20089,7 +20253,7 @@
                 <a:ea typeface="BIZ UDPゴシック" pitchFamily="34" charset="-122"/>
                 <a:cs typeface="BIZ UDPゴシック" pitchFamily="34" charset="-120"/>
               </a:rPr>
-              <a:t>学校の位置：地図サービスの所在地から作図（道路・河川は省略）。国の目安：文部科学省の適正規模・適正配置の手引（2015年）。</a:t>
+              <a:t>道のり・時間：Google マップの経路検索（2026年10月27日夜、片方向）。国の目安：文部科学省の適正規模・適正配置の手引（2015年）。</a:t>
             </a:r>
             <a:endParaRPr lang="en-US" sz="1200" dirty="0"/>
           </a:p>

</xml_diff>

<commit_message>
Apply third mock review fixes and add opinion sheets
- Neutral color for under-20 grades; darker grey text for contrast
- Uphill walking time for Kawada->Hoshina (46 min); all Hoshina legs now show the uphill direction
- Wakaho JHS history, evaluation method for the comparison table, preschool-to-JHS links
- New src/build_sheet.js: A4 opinion sheets for adults and for children (output/意見用紙.pdf)

Co-Authored-By: Claude Opus 5.5 <noreply@anthropic.com>
Claude-Session: https://claude.ai/code/session_01W71YS9cuG6jLhNCgQT7KJE
</commit_message>
<xml_diff>
--- a/output/若穂地区_住民説明会資料.pptx
+++ b/output/若穂地区_住民説明会資料.pptx
@@ -2321,7 +2321,7 @@
           <a:p>
             <a:r>
               <a:rPr lang="en-US" dirty="0"/>
-              <a:t>学校間の距離であり、各家庭からの通学距離ではないことを必ず口頭で伝える。道のりと時間はGoogle マップの経路検索（2026年10月27日の夜、片方向）。徒歩は大人の速さ、車は夜の交通量での値で、朝の通学時間帯は長くなることがある。保科小へ向かう徒歩は約100mの上り（若穂中→保科小 上り102m、綿内小→保科小 上り113m、保科小→川田小 下り104m）。各家庭からの距離と子どもの歩く速さでの実測は、事務局に依頼する。</a:t>
+              <a:t>学校間の距離であり、各家庭からの通学距離ではないことを必ず口頭で伝える。道のりと時間はGoogle マップの経路検索（2026年10月27日の夜）。保科小が入る区間（2・3・6）は、保科小へ向かう上りの向きの時間（川田小→保科小46分、逆の下りは36分）。徒歩は大人の速さ、車は夜の交通量での値で、朝の通学時間帯は長くなることがある。保科小へ向かう徒歩は約100mの上り（若穂中→保科小 上り102m、綿内小→保科小 上り113m、保科小→川田小 下り104m）。各家庭からの距離と子どもの歩く速さでの実測は、事務局に依頼する。</a:t>
             </a:r>
             <a:endParaRPr lang="en-US" dirty="0"/>
           </a:p>
@@ -4081,7 +4081,7 @@
           <a:p>
             <a:r>
               <a:rPr lang="en-US" dirty="0"/>
-              <a:t/>
+              <a:t>若穂中の統合（昭和36〜37年）を経験した世代の方に、当時のよかった点・苦労した点を聞く機会をつくることも提案できる。</a:t>
             </a:r>
             <a:endParaRPr lang="en-US" dirty="0"/>
           </a:p>
@@ -14822,7 +14822,7 @@
                 <a:ea typeface="BIZ UDPゴシック" pitchFamily="34" charset="-122"/>
                 <a:cs typeface="BIZ UDPゴシック" pitchFamily="34" charset="-120"/>
               </a:rPr>
-              <a:t>各選択肢の評価は、通学・施設・費用などの調査結果をもとに、委員会と地域で確認しながら記入します。</a:t>
+              <a:t>評価の付け方（案）：事務局の調査結果をもとに、委員会が視点ごとに「良い・課題あり・調査中」で記入し、地区別対話で確認します。</a:t>
             </a:r>
             <a:endParaRPr lang="en-US" sz="1200" dirty="0"/>
           </a:p>
@@ -16794,8 +16794,8 @@
         </p:nvSpPr>
         <p:spPr>
           <a:xfrm>
-            <a:off x="1901952" y="5650992"/>
-            <a:ext cx="548640" cy="228600"/>
+            <a:off x="1901952" y="5623560"/>
+            <a:ext cx="548640" cy="274320"/>
           </a:xfrm>
           <a:prstGeom prst="rect">
             <a:avLst/>
@@ -16811,7 +16811,7 @@
               <a:buNone/>
             </a:pPr>
             <a:r>
-              <a:rPr lang="en-US" sz="1100" dirty="0">
+              <a:rPr lang="en-US" sz="1300" dirty="0">
                 <a:solidFill>
                   <a:srgbClr val="56635D"/>
                 </a:solidFill>
@@ -16821,7 +16821,7 @@
               </a:rPr>
               <a:t>1km</a:t>
             </a:r>
-            <a:endParaRPr lang="en-US" sz="1100" dirty="0"/>
+            <a:endParaRPr lang="en-US" sz="1300" dirty="0"/>
           </a:p>
         </p:txBody>
       </p:sp>
@@ -16850,7 +16850,7 @@
               <a:buNone/>
             </a:pPr>
             <a:r>
-              <a:rPr lang="en-US" sz="1200" b="1" dirty="0">
+              <a:rPr lang="en-US" sz="1300" b="1" dirty="0">
                 <a:solidFill>
                   <a:srgbClr val="56635D"/>
                 </a:solidFill>
@@ -16860,7 +16860,7 @@
               </a:rPr>
               <a:t>↑ 北</a:t>
             </a:r>
-            <a:endParaRPr lang="en-US" sz="1200" dirty="0"/>
+            <a:endParaRPr lang="en-US" sz="1300" dirty="0"/>
           </a:p>
         </p:txBody>
       </p:sp>
@@ -16895,8 +16895,8 @@
         </p:nvSpPr>
         <p:spPr>
           <a:xfrm>
-            <a:off x="1298448" y="1618488"/>
-            <a:ext cx="1280160" cy="237744"/>
+            <a:off x="1298448" y="1600200"/>
+            <a:ext cx="1645920" cy="274320"/>
           </a:xfrm>
           <a:prstGeom prst="rect">
             <a:avLst/>
@@ -16912,7 +16912,7 @@
               <a:buNone/>
             </a:pPr>
             <a:r>
-              <a:rPr lang="en-US" sz="1100" dirty="0">
+              <a:rPr lang="en-US" sz="1300" dirty="0">
                 <a:solidFill>
                   <a:srgbClr val="56635D"/>
                 </a:solidFill>
@@ -16922,7 +16922,7 @@
               </a:rPr>
               <a:t>小学校どうし</a:t>
             </a:r>
-            <a:endParaRPr lang="en-US" sz="1100" dirty="0"/>
+            <a:endParaRPr lang="en-US" sz="1300" dirty="0"/>
           </a:p>
         </p:txBody>
       </p:sp>
@@ -16957,8 +16957,8 @@
         </p:nvSpPr>
         <p:spPr>
           <a:xfrm>
-            <a:off x="1298448" y="1892808"/>
-            <a:ext cx="1463040" cy="237744"/>
+            <a:off x="1298448" y="1874520"/>
+            <a:ext cx="1645920" cy="274320"/>
           </a:xfrm>
           <a:prstGeom prst="rect">
             <a:avLst/>
@@ -16974,7 +16974,7 @@
               <a:buNone/>
             </a:pPr>
             <a:r>
-              <a:rPr lang="en-US" sz="1100" dirty="0">
+              <a:rPr lang="en-US" sz="1300" dirty="0">
                 <a:solidFill>
                   <a:srgbClr val="56635D"/>
                 </a:solidFill>
@@ -16984,7 +16984,7 @@
               </a:rPr>
               <a:t>小学校と若穂中</a:t>
             </a:r>
-            <a:endParaRPr lang="en-US" sz="1100" dirty="0"/>
+            <a:endParaRPr lang="en-US" sz="1300" dirty="0"/>
           </a:p>
         </p:txBody>
       </p:sp>
@@ -16997,7 +16997,7 @@
         <p:spPr>
           <a:xfrm>
             <a:off x="822960" y="2240280"/>
-            <a:ext cx="2560320" cy="502920"/>
+            <a:ext cx="2743200" cy="594360"/>
           </a:xfrm>
           <a:prstGeom prst="rect">
             <a:avLst/>
@@ -17013,7 +17013,7 @@
               <a:buNone/>
             </a:pPr>
             <a:r>
-              <a:rPr lang="en-US" sz="1200" dirty="0">
+              <a:rPr lang="en-US" sz="1400" dirty="0">
                 <a:solidFill>
                   <a:srgbClr val="56635D"/>
                 </a:solidFill>
@@ -17023,14 +17023,14 @@
               </a:rPr>
               <a:t>保科小は、ほかの3校より</a:t>
             </a:r>
-            <a:endParaRPr lang="en-US" sz="1200" dirty="0"/>
+            <a:endParaRPr lang="en-US" sz="1400" dirty="0"/>
           </a:p>
           <a:p>
             <a:pPr indent="0" marL="0">
               <a:buNone/>
             </a:pPr>
             <a:r>
-              <a:rPr lang="en-US" sz="1200" dirty="0">
+              <a:rPr lang="en-US" sz="1400" dirty="0">
                 <a:solidFill>
                   <a:srgbClr val="56635D"/>
                 </a:solidFill>
@@ -17040,7 +17040,7 @@
               </a:rPr>
               <a:t>約100m高い所にあります</a:t>
             </a:r>
-            <a:endParaRPr lang="en-US" sz="1200" dirty="0"/>
+            <a:endParaRPr lang="en-US" sz="1400" dirty="0"/>
           </a:p>
         </p:txBody>
       </p:sp>
@@ -18266,7 +18266,7 @@
                           <a:ea typeface="BIZ UDPゴシック" pitchFamily="34" charset="-122"/>
                           <a:cs typeface="BIZ UDPゴシック" pitchFamily="34" charset="-120"/>
                         </a:rPr>
-                        <a:t>36分</a:t>
+                        <a:t>46分</a:t>
                       </a:r>
                       <a:endParaRPr lang="en-US" sz="1400" dirty="0">
                         <a:latin typeface="BIZ UDPゴシック" charset="0"/>
@@ -20253,7 +20253,7 @@
                 <a:ea typeface="BIZ UDPゴシック" pitchFamily="34" charset="-122"/>
                 <a:cs typeface="BIZ UDPゴシック" pitchFamily="34" charset="-120"/>
               </a:rPr>
-              <a:t>道のり・時間：Google マップの経路検索（2026年10月27日夜、片方向）。国の目安：文部科学省の適正規模・適正配置の手引（2015年）。</a:t>
+              <a:t>Google マップの経路検索（2026年10月27日夜）。2・3・6は保科小へ向かう上りの時間。国の目安：文部科学省の手引（2015年）。</a:t>
             </a:r>
             <a:endParaRPr lang="en-US" sz="1200" dirty="0"/>
           </a:p>
@@ -22032,7 +22032,7 @@
                       <a:r>
                         <a:rPr lang="en-US" sz="1600" dirty="0">
                           <a:solidFill>
-                            <a:srgbClr val="9AA59F"/>
+                            <a:srgbClr val="56635D"/>
                           </a:solidFill>
                           <a:latin typeface="BIZ UDPゴシック" pitchFamily="34" charset="0"/>
                           <a:ea typeface="BIZ UDPゴシック" pitchFamily="34" charset="-122"/>
@@ -22374,7 +22374,7 @@
                       <a:r>
                         <a:rPr lang="en-US" sz="1600" dirty="0">
                           <a:solidFill>
-                            <a:srgbClr val="9AA59F"/>
+                            <a:srgbClr val="56635D"/>
                           </a:solidFill>
                           <a:latin typeface="BIZ UDPゴシック" pitchFamily="34" charset="0"/>
                           <a:ea typeface="BIZ UDPゴシック" pitchFamily="34" charset="-122"/>
@@ -22716,7 +22716,7 @@
                       <a:r>
                         <a:rPr lang="en-US" sz="1600" dirty="0">
                           <a:solidFill>
-                            <a:srgbClr val="9AA59F"/>
+                            <a:srgbClr val="56635D"/>
                           </a:solidFill>
                           <a:latin typeface="BIZ UDPゴシック" pitchFamily="34" charset="0"/>
                           <a:ea typeface="BIZ UDPゴシック" pitchFamily="34" charset="-122"/>
@@ -23058,7 +23058,7 @@
                       <a:r>
                         <a:rPr lang="en-US" sz="1600" dirty="0">
                           <a:solidFill>
-                            <a:srgbClr val="9AA59F"/>
+                            <a:srgbClr val="56635D"/>
                           </a:solidFill>
                           <a:latin typeface="BIZ UDPゴシック" pitchFamily="34" charset="0"/>
                           <a:ea typeface="BIZ UDPゴシック" pitchFamily="34" charset="-122"/>
@@ -25075,7 +25075,7 @@
                 <a:ea typeface="BIZ UDPゴシック" pitchFamily="34" charset="-122"/>
                 <a:cs typeface="BIZ UDPゴシック" pitchFamily="34" charset="-120"/>
               </a:rPr>
-              <a:t>小中の連携</a:t>
+              <a:t>保育園から中学校までの連携</a:t>
             </a:r>
             <a:endParaRPr lang="en-US" sz="2100" dirty="0"/>
           </a:p>
@@ -25114,7 +25114,7 @@
                 <a:ea typeface="BIZ UDPゴシック" pitchFamily="34" charset="-122"/>
                 <a:cs typeface="BIZ UDPゴシック" pitchFamily="34" charset="-120"/>
               </a:rPr>
-              <a:t>中学校の先生による出前授業、小学6年生の中学校体験</a:t>
+              <a:t>保育園・幼稚園児の学校体験、中学校の先生による出前授業、小6の中学校体験</a:t>
             </a:r>
             <a:endParaRPr lang="en-US" sz="1600" dirty="0"/>
           </a:p>
@@ -34626,7 +34626,7 @@
             <a:avLst/>
           </a:prstGeom>
           <a:solidFill>
-            <a:srgbClr val="FCEBE6"/>
+            <a:srgbClr val="DDE7EF"/>
           </a:solidFill>
           <a:ln w="12700">
             <a:solidFill>
@@ -36349,7 +36349,7 @@
                       <a:r>
                         <a:rPr lang="en-US" sz="1800" b="1" dirty="0">
                           <a:solidFill>
-                            <a:srgbClr val="A3402C"/>
+                            <a:srgbClr val="1E2A26"/>
                           </a:solidFill>
                           <a:latin typeface="BIZ UDPゴシック" pitchFamily="34" charset="0"/>
                           <a:ea typeface="BIZ UDPゴシック" pitchFamily="34" charset="-122"/>
@@ -36402,7 +36402,7 @@
                       <a:tailEnd type="none" w="med" len="med"/>
                     </a:lnB>
                     <a:solidFill>
-                      <a:srgbClr val="FCEBE6"/>
+                      <a:srgbClr val="DDE7EF"/>
                     </a:solidFill>
                   </a:tcPr>
                 </a:tc>
@@ -36417,7 +36417,7 @@
                       <a:r>
                         <a:rPr lang="en-US" sz="1800" b="1" dirty="0">
                           <a:solidFill>
-                            <a:srgbClr val="A3402C"/>
+                            <a:srgbClr val="1E2A26"/>
                           </a:solidFill>
                           <a:latin typeface="BIZ UDPゴシック" pitchFamily="34" charset="0"/>
                           <a:ea typeface="BIZ UDPゴシック" pitchFamily="34" charset="-122"/>
@@ -36470,7 +36470,7 @@
                       <a:tailEnd type="none" w="med" len="med"/>
                     </a:lnB>
                     <a:solidFill>
-                      <a:srgbClr val="FCEBE6"/>
+                      <a:srgbClr val="DDE7EF"/>
                     </a:solidFill>
                   </a:tcPr>
                 </a:tc>
@@ -36485,7 +36485,7 @@
                       <a:r>
                         <a:rPr lang="en-US" sz="1800" b="1" dirty="0">
                           <a:solidFill>
-                            <a:srgbClr val="A3402C"/>
+                            <a:srgbClr val="1E2A26"/>
                           </a:solidFill>
                           <a:latin typeface="BIZ UDPゴシック" pitchFamily="34" charset="0"/>
                           <a:ea typeface="BIZ UDPゴシック" pitchFamily="34" charset="-122"/>
@@ -36538,7 +36538,7 @@
                       <a:tailEnd type="none" w="med" len="med"/>
                     </a:lnB>
                     <a:solidFill>
-                      <a:srgbClr val="FCEBE6"/>
+                      <a:srgbClr val="DDE7EF"/>
                     </a:solidFill>
                   </a:tcPr>
                 </a:tc>
@@ -36553,7 +36553,7 @@
                       <a:r>
                         <a:rPr lang="en-US" sz="1800" b="1" dirty="0">
                           <a:solidFill>
-                            <a:srgbClr val="A3402C"/>
+                            <a:srgbClr val="1E2A26"/>
                           </a:solidFill>
                           <a:latin typeface="BIZ UDPゴシック" pitchFamily="34" charset="0"/>
                           <a:ea typeface="BIZ UDPゴシック" pitchFamily="34" charset="-122"/>
@@ -36606,7 +36606,7 @@
                       <a:tailEnd type="none" w="med" len="med"/>
                     </a:lnB>
                     <a:solidFill>
-                      <a:srgbClr val="FCEBE6"/>
+                      <a:srgbClr val="DDE7EF"/>
                     </a:solidFill>
                   </a:tcPr>
                 </a:tc>
@@ -36621,7 +36621,7 @@
                       <a:r>
                         <a:rPr lang="en-US" sz="1800" b="1" dirty="0">
                           <a:solidFill>
-                            <a:srgbClr val="A3402C"/>
+                            <a:srgbClr val="1E2A26"/>
                           </a:solidFill>
                           <a:latin typeface="BIZ UDPゴシック" pitchFamily="34" charset="0"/>
                           <a:ea typeface="BIZ UDPゴシック" pitchFamily="34" charset="-122"/>
@@ -36674,7 +36674,7 @@
                       <a:tailEnd type="none" w="med" len="med"/>
                     </a:lnB>
                     <a:solidFill>
-                      <a:srgbClr val="FCEBE6"/>
+                      <a:srgbClr val="DDE7EF"/>
                     </a:solidFill>
                   </a:tcPr>
                 </a:tc>
@@ -36689,7 +36689,7 @@
                       <a:r>
                         <a:rPr lang="en-US" sz="1800" b="1" dirty="0">
                           <a:solidFill>
-                            <a:srgbClr val="A3402C"/>
+                            <a:srgbClr val="1E2A26"/>
                           </a:solidFill>
                           <a:latin typeface="BIZ UDPゴシック" pitchFamily="34" charset="0"/>
                           <a:ea typeface="BIZ UDPゴシック" pitchFamily="34" charset="-122"/>
@@ -36742,7 +36742,7 @@
                       <a:tailEnd type="none" w="med" len="med"/>
                     </a:lnB>
                     <a:solidFill>
-                      <a:srgbClr val="FCEBE6"/>
+                      <a:srgbClr val="DDE7EF"/>
                     </a:solidFill>
                   </a:tcPr>
                 </a:tc>
@@ -36963,7 +36963,7 @@
                       <a:r>
                         <a:rPr lang="en-US" sz="1800" b="1" dirty="0">
                           <a:solidFill>
-                            <a:srgbClr val="A3402C"/>
+                            <a:srgbClr val="1E2A26"/>
                           </a:solidFill>
                           <a:latin typeface="BIZ UDPゴシック" pitchFamily="34" charset="0"/>
                           <a:ea typeface="BIZ UDPゴシック" pitchFamily="34" charset="-122"/>
@@ -37016,7 +37016,7 @@
                       <a:tailEnd type="none" w="med" len="med"/>
                     </a:lnB>
                     <a:solidFill>
-                      <a:srgbClr val="FCEBE6"/>
+                      <a:srgbClr val="DDE7EF"/>
                     </a:solidFill>
                   </a:tcPr>
                 </a:tc>
@@ -37031,7 +37031,7 @@
                       <a:r>
                         <a:rPr lang="en-US" sz="1800" b="1" dirty="0">
                           <a:solidFill>
-                            <a:srgbClr val="A3402C"/>
+                            <a:srgbClr val="1E2A26"/>
                           </a:solidFill>
                           <a:latin typeface="BIZ UDPゴシック" pitchFamily="34" charset="0"/>
                           <a:ea typeface="BIZ UDPゴシック" pitchFamily="34" charset="-122"/>
@@ -37084,7 +37084,7 @@
                       <a:tailEnd type="none" w="med" len="med"/>
                     </a:lnB>
                     <a:solidFill>
-                      <a:srgbClr val="FCEBE6"/>
+                      <a:srgbClr val="DDE7EF"/>
                     </a:solidFill>
                   </a:tcPr>
                 </a:tc>
@@ -37099,7 +37099,7 @@
                       <a:r>
                         <a:rPr lang="en-US" sz="1800" b="1" dirty="0">
                           <a:solidFill>
-                            <a:srgbClr val="A3402C"/>
+                            <a:srgbClr val="1E2A26"/>
                           </a:solidFill>
                           <a:latin typeface="BIZ UDPゴシック" pitchFamily="34" charset="0"/>
                           <a:ea typeface="BIZ UDPゴシック" pitchFamily="34" charset="-122"/>
@@ -37152,7 +37152,7 @@
                       <a:tailEnd type="none" w="med" len="med"/>
                     </a:lnB>
                     <a:solidFill>
-                      <a:srgbClr val="FCEBE6"/>
+                      <a:srgbClr val="DDE7EF"/>
                     </a:solidFill>
                   </a:tcPr>
                 </a:tc>
@@ -37167,7 +37167,7 @@
                       <a:r>
                         <a:rPr lang="en-US" sz="1800" b="1" dirty="0">
                           <a:solidFill>
-                            <a:srgbClr val="A3402C"/>
+                            <a:srgbClr val="1E2A26"/>
                           </a:solidFill>
                           <a:latin typeface="BIZ UDPゴシック" pitchFamily="34" charset="0"/>
                           <a:ea typeface="BIZ UDPゴシック" pitchFamily="34" charset="-122"/>
@@ -37220,7 +37220,7 @@
                       <a:tailEnd type="none" w="med" len="med"/>
                     </a:lnB>
                     <a:solidFill>
-                      <a:srgbClr val="FCEBE6"/>
+                      <a:srgbClr val="DDE7EF"/>
                     </a:solidFill>
                   </a:tcPr>
                 </a:tc>
@@ -37235,7 +37235,7 @@
                       <a:r>
                         <a:rPr lang="en-US" sz="1800" b="1" dirty="0">
                           <a:solidFill>
-                            <a:srgbClr val="A3402C"/>
+                            <a:srgbClr val="1E2A26"/>
                           </a:solidFill>
                           <a:latin typeface="BIZ UDPゴシック" pitchFamily="34" charset="0"/>
                           <a:ea typeface="BIZ UDPゴシック" pitchFamily="34" charset="-122"/>
@@ -37288,7 +37288,7 @@
                       <a:tailEnd type="none" w="med" len="med"/>
                     </a:lnB>
                     <a:solidFill>
-                      <a:srgbClr val="FCEBE6"/>
+                      <a:srgbClr val="DDE7EF"/>
                     </a:solidFill>
                   </a:tcPr>
                 </a:tc>
@@ -37577,7 +37577,7 @@
                       <a:r>
                         <a:rPr lang="en-US" sz="1800" b="1" dirty="0">
                           <a:solidFill>
-                            <a:srgbClr val="A3402C"/>
+                            <a:srgbClr val="1E2A26"/>
                           </a:solidFill>
                           <a:latin typeface="BIZ UDPゴシック" pitchFamily="34" charset="0"/>
                           <a:ea typeface="BIZ UDPゴシック" pitchFamily="34" charset="-122"/>
@@ -37630,7 +37630,7 @@
                       <a:tailEnd type="none" w="med" len="med"/>
                     </a:lnB>
                     <a:solidFill>
-                      <a:srgbClr val="FCEBE6"/>
+                      <a:srgbClr val="DDE7EF"/>
                     </a:solidFill>
                   </a:tcPr>
                 </a:tc>
@@ -37645,7 +37645,7 @@
                       <a:r>
                         <a:rPr lang="en-US" sz="1800" b="1" dirty="0">
                           <a:solidFill>
-                            <a:srgbClr val="A3402C"/>
+                            <a:srgbClr val="1E2A26"/>
                           </a:solidFill>
                           <a:latin typeface="BIZ UDPゴシック" pitchFamily="34" charset="0"/>
                           <a:ea typeface="BIZ UDPゴシック" pitchFamily="34" charset="-122"/>
@@ -37698,7 +37698,7 @@
                       <a:tailEnd type="none" w="med" len="med"/>
                     </a:lnB>
                     <a:solidFill>
-                      <a:srgbClr val="FCEBE6"/>
+                      <a:srgbClr val="DDE7EF"/>
                     </a:solidFill>
                   </a:tcPr>
                 </a:tc>
@@ -37713,7 +37713,7 @@
                       <a:r>
                         <a:rPr lang="en-US" sz="1800" b="1" dirty="0">
                           <a:solidFill>
-                            <a:srgbClr val="A3402C"/>
+                            <a:srgbClr val="1E2A26"/>
                           </a:solidFill>
                           <a:latin typeface="BIZ UDPゴシック" pitchFamily="34" charset="0"/>
                           <a:ea typeface="BIZ UDPゴシック" pitchFamily="34" charset="-122"/>
@@ -37766,7 +37766,7 @@
                       <a:tailEnd type="none" w="med" len="med"/>
                     </a:lnB>
                     <a:solidFill>
-                      <a:srgbClr val="FCEBE6"/>
+                      <a:srgbClr val="DDE7EF"/>
                     </a:solidFill>
                   </a:tcPr>
                 </a:tc>
@@ -37781,7 +37781,7 @@
                       <a:r>
                         <a:rPr lang="en-US" sz="1800" b="1" dirty="0">
                           <a:solidFill>
-                            <a:srgbClr val="A3402C"/>
+                            <a:srgbClr val="1E2A26"/>
                           </a:solidFill>
                           <a:latin typeface="BIZ UDPゴシック" pitchFamily="34" charset="0"/>
                           <a:ea typeface="BIZ UDPゴシック" pitchFamily="34" charset="-122"/>
@@ -37834,7 +37834,7 @@
                       <a:tailEnd type="none" w="med" len="med"/>
                     </a:lnB>
                     <a:solidFill>
-                      <a:srgbClr val="FCEBE6"/>
+                      <a:srgbClr val="DDE7EF"/>
                     </a:solidFill>
                   </a:tcPr>
                 </a:tc>
@@ -38191,7 +38191,7 @@
                       <a:r>
                         <a:rPr lang="en-US" sz="1800" b="1" dirty="0">
                           <a:solidFill>
-                            <a:srgbClr val="A3402C"/>
+                            <a:srgbClr val="1E2A26"/>
                           </a:solidFill>
                           <a:latin typeface="BIZ UDPゴシック" pitchFamily="34" charset="0"/>
                           <a:ea typeface="BIZ UDPゴシック" pitchFamily="34" charset="-122"/>
@@ -38244,7 +38244,7 @@
                       <a:tailEnd type="none" w="med" len="med"/>
                     </a:lnB>
                     <a:solidFill>
-                      <a:srgbClr val="FCEBE6"/>
+                      <a:srgbClr val="DDE7EF"/>
                     </a:solidFill>
                   </a:tcPr>
                 </a:tc>
@@ -38259,7 +38259,7 @@
                       <a:r>
                         <a:rPr lang="en-US" sz="1800" b="1" dirty="0">
                           <a:solidFill>
-                            <a:srgbClr val="A3402C"/>
+                            <a:srgbClr val="1E2A26"/>
                           </a:solidFill>
                           <a:latin typeface="BIZ UDPゴシック" pitchFamily="34" charset="0"/>
                           <a:ea typeface="BIZ UDPゴシック" pitchFamily="34" charset="-122"/>
@@ -38312,7 +38312,7 @@
                       <a:tailEnd type="none" w="med" len="med"/>
                     </a:lnB>
                     <a:solidFill>
-                      <a:srgbClr val="FCEBE6"/>
+                      <a:srgbClr val="DDE7EF"/>
                     </a:solidFill>
                   </a:tcPr>
                 </a:tc>
@@ -38327,7 +38327,7 @@
                       <a:r>
                         <a:rPr lang="en-US" sz="1800" b="1" dirty="0">
                           <a:solidFill>
-                            <a:srgbClr val="A3402C"/>
+                            <a:srgbClr val="1E2A26"/>
                           </a:solidFill>
                           <a:latin typeface="BIZ UDPゴシック" pitchFamily="34" charset="0"/>
                           <a:ea typeface="BIZ UDPゴシック" pitchFamily="34" charset="-122"/>
@@ -38380,7 +38380,7 @@
                       <a:tailEnd type="none" w="med" len="med"/>
                     </a:lnB>
                     <a:solidFill>
-                      <a:srgbClr val="FCEBE6"/>
+                      <a:srgbClr val="DDE7EF"/>
                     </a:solidFill>
                   </a:tcPr>
                 </a:tc>
@@ -38805,7 +38805,7 @@
                       <a:r>
                         <a:rPr lang="en-US" sz="1800" b="1" dirty="0">
                           <a:solidFill>
-                            <a:srgbClr val="A3402C"/>
+                            <a:srgbClr val="1E2A26"/>
                           </a:solidFill>
                           <a:latin typeface="BIZ UDPゴシック" pitchFamily="34" charset="0"/>
                           <a:ea typeface="BIZ UDPゴシック" pitchFamily="34" charset="-122"/>
@@ -38858,7 +38858,7 @@
                       <a:tailEnd type="none" w="med" len="med"/>
                     </a:lnB>
                     <a:solidFill>
-                      <a:srgbClr val="FCEBE6"/>
+                      <a:srgbClr val="DDE7EF"/>
                     </a:solidFill>
                   </a:tcPr>
                 </a:tc>
@@ -38873,7 +38873,7 @@
                       <a:r>
                         <a:rPr lang="en-US" sz="1800" b="1" dirty="0">
                           <a:solidFill>
-                            <a:srgbClr val="A3402C"/>
+                            <a:srgbClr val="1E2A26"/>
                           </a:solidFill>
                           <a:latin typeface="BIZ UDPゴシック" pitchFamily="34" charset="0"/>
                           <a:ea typeface="BIZ UDPゴシック" pitchFamily="34" charset="-122"/>
@@ -38926,7 +38926,7 @@
                       <a:tailEnd type="none" w="med" len="med"/>
                     </a:lnB>
                     <a:solidFill>
-                      <a:srgbClr val="FCEBE6"/>
+                      <a:srgbClr val="DDE7EF"/>
                     </a:solidFill>
                   </a:tcPr>
                 </a:tc>
@@ -39419,7 +39419,7 @@
                       <a:r>
                         <a:rPr lang="en-US" sz="1800" b="1" dirty="0">
                           <a:solidFill>
-                            <a:srgbClr val="A3402C"/>
+                            <a:srgbClr val="1E2A26"/>
                           </a:solidFill>
                           <a:latin typeface="BIZ UDPゴシック" pitchFamily="34" charset="0"/>
                           <a:ea typeface="BIZ UDPゴシック" pitchFamily="34" charset="-122"/>
@@ -39472,7 +39472,7 @@
                       <a:tailEnd type="none" w="med" len="med"/>
                     </a:lnB>
                     <a:solidFill>
-                      <a:srgbClr val="FCEBE6"/>
+                      <a:srgbClr val="DDE7EF"/>
                     </a:solidFill>
                   </a:tcPr>
                 </a:tc>
@@ -40042,7 +40042,7 @@
             <a:avLst/>
           </a:prstGeom>
           <a:solidFill>
-            <a:srgbClr val="FCEBE6"/>
+            <a:srgbClr val="DDE7EF"/>
           </a:solidFill>
           <a:ln w="12700">
             <a:solidFill>
@@ -41121,7 +41121,7 @@
                       <a:r>
                         <a:rPr lang="en-US" sz="1800" b="1" dirty="0">
                           <a:solidFill>
-                            <a:srgbClr val="A3402C"/>
+                            <a:srgbClr val="1E2A26"/>
                           </a:solidFill>
                           <a:latin typeface="BIZ UDPゴシック" pitchFamily="34" charset="0"/>
                           <a:ea typeface="BIZ UDPゴシック" pitchFamily="34" charset="-122"/>
@@ -41174,7 +41174,7 @@
                       <a:tailEnd type="none" w="med" len="med"/>
                     </a:lnB>
                     <a:solidFill>
-                      <a:srgbClr val="FCEBE6"/>
+                      <a:srgbClr val="DDE7EF"/>
                     </a:solidFill>
                   </a:tcPr>
                 </a:tc>
@@ -41189,7 +41189,7 @@
                       <a:r>
                         <a:rPr lang="en-US" sz="1800" b="1" dirty="0">
                           <a:solidFill>
-                            <a:srgbClr val="A3402C"/>
+                            <a:srgbClr val="1E2A26"/>
                           </a:solidFill>
                           <a:latin typeface="BIZ UDPゴシック" pitchFamily="34" charset="0"/>
                           <a:ea typeface="BIZ UDPゴシック" pitchFamily="34" charset="-122"/>
@@ -41242,7 +41242,7 @@
                       <a:tailEnd type="none" w="med" len="med"/>
                     </a:lnB>
                     <a:solidFill>
-                      <a:srgbClr val="FCEBE6"/>
+                      <a:srgbClr val="DDE7EF"/>
                     </a:solidFill>
                   </a:tcPr>
                 </a:tc>
@@ -41257,7 +41257,7 @@
                       <a:r>
                         <a:rPr lang="en-US" sz="1800" b="1" dirty="0">
                           <a:solidFill>
-                            <a:srgbClr val="A3402C"/>
+                            <a:srgbClr val="1E2A26"/>
                           </a:solidFill>
                           <a:latin typeface="BIZ UDPゴシック" pitchFamily="34" charset="0"/>
                           <a:ea typeface="BIZ UDPゴシック" pitchFamily="34" charset="-122"/>
@@ -41310,7 +41310,7 @@
                       <a:tailEnd type="none" w="med" len="med"/>
                     </a:lnB>
                     <a:solidFill>
-                      <a:srgbClr val="FCEBE6"/>
+                      <a:srgbClr val="DDE7EF"/>
                     </a:solidFill>
                   </a:tcPr>
                 </a:tc>
@@ -41325,7 +41325,7 @@
                       <a:r>
                         <a:rPr lang="en-US" sz="1800" b="1" dirty="0">
                           <a:solidFill>
-                            <a:srgbClr val="A3402C"/>
+                            <a:srgbClr val="1E2A26"/>
                           </a:solidFill>
                           <a:latin typeface="BIZ UDPゴシック" pitchFamily="34" charset="0"/>
                           <a:ea typeface="BIZ UDPゴシック" pitchFamily="34" charset="-122"/>
@@ -41378,7 +41378,7 @@
                       <a:tailEnd type="none" w="med" len="med"/>
                     </a:lnB>
                     <a:solidFill>
-                      <a:srgbClr val="FCEBE6"/>
+                      <a:srgbClr val="DDE7EF"/>
                     </a:solidFill>
                   </a:tcPr>
                 </a:tc>
@@ -41393,7 +41393,7 @@
                       <a:r>
                         <a:rPr lang="en-US" sz="1800" b="1" dirty="0">
                           <a:solidFill>
-                            <a:srgbClr val="A3402C"/>
+                            <a:srgbClr val="1E2A26"/>
                           </a:solidFill>
                           <a:latin typeface="BIZ UDPゴシック" pitchFamily="34" charset="0"/>
                           <a:ea typeface="BIZ UDPゴシック" pitchFamily="34" charset="-122"/>
@@ -41446,7 +41446,7 @@
                       <a:tailEnd type="none" w="med" len="med"/>
                     </a:lnB>
                     <a:solidFill>
-                      <a:srgbClr val="FCEBE6"/>
+                      <a:srgbClr val="DDE7EF"/>
                     </a:solidFill>
                   </a:tcPr>
                 </a:tc>
@@ -41461,7 +41461,7 @@
                       <a:r>
                         <a:rPr lang="en-US" sz="1800" b="1" dirty="0">
                           <a:solidFill>
-                            <a:srgbClr val="A3402C"/>
+                            <a:srgbClr val="1E2A26"/>
                           </a:solidFill>
                           <a:latin typeface="BIZ UDPゴシック" pitchFamily="34" charset="0"/>
                           <a:ea typeface="BIZ UDPゴシック" pitchFamily="34" charset="-122"/>
@@ -41514,7 +41514,7 @@
                       <a:tailEnd type="none" w="med" len="med"/>
                     </a:lnB>
                     <a:solidFill>
-                      <a:srgbClr val="FCEBE6"/>
+                      <a:srgbClr val="DDE7EF"/>
                     </a:solidFill>
                   </a:tcPr>
                 </a:tc>
@@ -41529,7 +41529,7 @@
                       <a:r>
                         <a:rPr lang="en-US" sz="1800" b="1" dirty="0">
                           <a:solidFill>
-                            <a:srgbClr val="A3402C"/>
+                            <a:srgbClr val="1E2A26"/>
                           </a:solidFill>
                           <a:latin typeface="BIZ UDPゴシック" pitchFamily="34" charset="0"/>
                           <a:ea typeface="BIZ UDPゴシック" pitchFamily="34" charset="-122"/>
@@ -41582,7 +41582,7 @@
                       <a:tailEnd type="none" w="med" len="med"/>
                     </a:lnB>
                     <a:solidFill>
-                      <a:srgbClr val="FCEBE6"/>
+                      <a:srgbClr val="DDE7EF"/>
                     </a:solidFill>
                   </a:tcPr>
                 </a:tc>
@@ -41667,7 +41667,7 @@
                       <a:r>
                         <a:rPr lang="en-US" sz="1800" b="1" dirty="0">
                           <a:solidFill>
-                            <a:srgbClr val="A3402C"/>
+                            <a:srgbClr val="1E2A26"/>
                           </a:solidFill>
                           <a:latin typeface="BIZ UDPゴシック" pitchFamily="34" charset="0"/>
                           <a:ea typeface="BIZ UDPゴシック" pitchFamily="34" charset="-122"/>
@@ -41720,7 +41720,7 @@
                       <a:tailEnd type="none" w="med" len="med"/>
                     </a:lnB>
                     <a:solidFill>
-                      <a:srgbClr val="FCEBE6"/>
+                      <a:srgbClr val="DDE7EF"/>
                     </a:solidFill>
                   </a:tcPr>
                 </a:tc>
@@ -41735,7 +41735,7 @@
                       <a:r>
                         <a:rPr lang="en-US" sz="1800" b="1" dirty="0">
                           <a:solidFill>
-                            <a:srgbClr val="A3402C"/>
+                            <a:srgbClr val="1E2A26"/>
                           </a:solidFill>
                           <a:latin typeface="BIZ UDPゴシック" pitchFamily="34" charset="0"/>
                           <a:ea typeface="BIZ UDPゴシック" pitchFamily="34" charset="-122"/>
@@ -41788,7 +41788,7 @@
                       <a:tailEnd type="none" w="med" len="med"/>
                     </a:lnB>
                     <a:solidFill>
-                      <a:srgbClr val="FCEBE6"/>
+                      <a:srgbClr val="DDE7EF"/>
                     </a:solidFill>
                   </a:tcPr>
                 </a:tc>
@@ -41803,7 +41803,7 @@
                       <a:r>
                         <a:rPr lang="en-US" sz="1800" b="1" dirty="0">
                           <a:solidFill>
-                            <a:srgbClr val="A3402C"/>
+                            <a:srgbClr val="1E2A26"/>
                           </a:solidFill>
                           <a:latin typeface="BIZ UDPゴシック" pitchFamily="34" charset="0"/>
                           <a:ea typeface="BIZ UDPゴシック" pitchFamily="34" charset="-122"/>
@@ -41856,7 +41856,7 @@
                       <a:tailEnd type="none" w="med" len="med"/>
                     </a:lnB>
                     <a:solidFill>
-                      <a:srgbClr val="FCEBE6"/>
+                      <a:srgbClr val="DDE7EF"/>
                     </a:solidFill>
                   </a:tcPr>
                 </a:tc>
@@ -41871,7 +41871,7 @@
                       <a:r>
                         <a:rPr lang="en-US" sz="1800" b="1" dirty="0">
                           <a:solidFill>
-                            <a:srgbClr val="A3402C"/>
+                            <a:srgbClr val="1E2A26"/>
                           </a:solidFill>
                           <a:latin typeface="BIZ UDPゴシック" pitchFamily="34" charset="0"/>
                           <a:ea typeface="BIZ UDPゴシック" pitchFamily="34" charset="-122"/>
@@ -41924,7 +41924,7 @@
                       <a:tailEnd type="none" w="med" len="med"/>
                     </a:lnB>
                     <a:solidFill>
-                      <a:srgbClr val="FCEBE6"/>
+                      <a:srgbClr val="DDE7EF"/>
                     </a:solidFill>
                   </a:tcPr>
                 </a:tc>
@@ -41939,7 +41939,7 @@
                       <a:r>
                         <a:rPr lang="en-US" sz="1800" b="1" dirty="0">
                           <a:solidFill>
-                            <a:srgbClr val="A3402C"/>
+                            <a:srgbClr val="1E2A26"/>
                           </a:solidFill>
                           <a:latin typeface="BIZ UDPゴシック" pitchFamily="34" charset="0"/>
                           <a:ea typeface="BIZ UDPゴシック" pitchFamily="34" charset="-122"/>
@@ -41992,7 +41992,7 @@
                       <a:tailEnd type="none" w="med" len="med"/>
                     </a:lnB>
                     <a:solidFill>
-                      <a:srgbClr val="FCEBE6"/>
+                      <a:srgbClr val="DDE7EF"/>
                     </a:solidFill>
                   </a:tcPr>
                 </a:tc>
@@ -42007,7 +42007,7 @@
                       <a:r>
                         <a:rPr lang="en-US" sz="1800" b="1" dirty="0">
                           <a:solidFill>
-                            <a:srgbClr val="A3402C"/>
+                            <a:srgbClr val="1E2A26"/>
                           </a:solidFill>
                           <a:latin typeface="BIZ UDPゴシック" pitchFamily="34" charset="0"/>
                           <a:ea typeface="BIZ UDPゴシック" pitchFamily="34" charset="-122"/>
@@ -42060,7 +42060,7 @@
                       <a:tailEnd type="none" w="med" len="med"/>
                     </a:lnB>
                     <a:solidFill>
-                      <a:srgbClr val="FCEBE6"/>
+                      <a:srgbClr val="DDE7EF"/>
                     </a:solidFill>
                   </a:tcPr>
                 </a:tc>
@@ -42075,7 +42075,7 @@
                       <a:r>
                         <a:rPr lang="en-US" sz="1800" b="1" dirty="0">
                           <a:solidFill>
-                            <a:srgbClr val="A3402C"/>
+                            <a:srgbClr val="1E2A26"/>
                           </a:solidFill>
                           <a:latin typeface="BIZ UDPゴシック" pitchFamily="34" charset="0"/>
                           <a:ea typeface="BIZ UDPゴシック" pitchFamily="34" charset="-122"/>
@@ -42128,7 +42128,7 @@
                       <a:tailEnd type="none" w="med" len="med"/>
                     </a:lnB>
                     <a:solidFill>
-                      <a:srgbClr val="FCEBE6"/>
+                      <a:srgbClr val="DDE7EF"/>
                     </a:solidFill>
                   </a:tcPr>
                 </a:tc>
@@ -42213,7 +42213,7 @@
                       <a:r>
                         <a:rPr lang="en-US" sz="1800" b="1" dirty="0">
                           <a:solidFill>
-                            <a:srgbClr val="A3402C"/>
+                            <a:srgbClr val="1E2A26"/>
                           </a:solidFill>
                           <a:latin typeface="BIZ UDPゴシック" pitchFamily="34" charset="0"/>
                           <a:ea typeface="BIZ UDPゴシック" pitchFamily="34" charset="-122"/>
@@ -42266,7 +42266,7 @@
                       <a:tailEnd type="none" w="med" len="med"/>
                     </a:lnB>
                     <a:solidFill>
-                      <a:srgbClr val="FCEBE6"/>
+                      <a:srgbClr val="DDE7EF"/>
                     </a:solidFill>
                   </a:tcPr>
                 </a:tc>
@@ -42281,7 +42281,7 @@
                       <a:r>
                         <a:rPr lang="en-US" sz="1800" b="1" dirty="0">
                           <a:solidFill>
-                            <a:srgbClr val="A3402C"/>
+                            <a:srgbClr val="1E2A26"/>
                           </a:solidFill>
                           <a:latin typeface="BIZ UDPゴシック" pitchFamily="34" charset="0"/>
                           <a:ea typeface="BIZ UDPゴシック" pitchFamily="34" charset="-122"/>
@@ -42334,7 +42334,7 @@
                       <a:tailEnd type="none" w="med" len="med"/>
                     </a:lnB>
                     <a:solidFill>
-                      <a:srgbClr val="FCEBE6"/>
+                      <a:srgbClr val="DDE7EF"/>
                     </a:solidFill>
                   </a:tcPr>
                 </a:tc>
@@ -42349,7 +42349,7 @@
                       <a:r>
                         <a:rPr lang="en-US" sz="1800" b="1" dirty="0">
                           <a:solidFill>
-                            <a:srgbClr val="A3402C"/>
+                            <a:srgbClr val="1E2A26"/>
                           </a:solidFill>
                           <a:latin typeface="BIZ UDPゴシック" pitchFamily="34" charset="0"/>
                           <a:ea typeface="BIZ UDPゴシック" pitchFamily="34" charset="-122"/>
@@ -42402,7 +42402,7 @@
                       <a:tailEnd type="none" w="med" len="med"/>
                     </a:lnB>
                     <a:solidFill>
-                      <a:srgbClr val="FCEBE6"/>
+                      <a:srgbClr val="DDE7EF"/>
                     </a:solidFill>
                   </a:tcPr>
                 </a:tc>
@@ -42417,7 +42417,7 @@
                       <a:r>
                         <a:rPr lang="en-US" sz="1800" b="1" dirty="0">
                           <a:solidFill>
-                            <a:srgbClr val="A3402C"/>
+                            <a:srgbClr val="1E2A26"/>
                           </a:solidFill>
                           <a:latin typeface="BIZ UDPゴシック" pitchFamily="34" charset="0"/>
                           <a:ea typeface="BIZ UDPゴシック" pitchFamily="34" charset="-122"/>
@@ -42470,7 +42470,7 @@
                       <a:tailEnd type="none" w="med" len="med"/>
                     </a:lnB>
                     <a:solidFill>
-                      <a:srgbClr val="FCEBE6"/>
+                      <a:srgbClr val="DDE7EF"/>
                     </a:solidFill>
                   </a:tcPr>
                 </a:tc>
@@ -42485,7 +42485,7 @@
                       <a:r>
                         <a:rPr lang="en-US" sz="1800" b="1" dirty="0">
                           <a:solidFill>
-                            <a:srgbClr val="A3402C"/>
+                            <a:srgbClr val="1E2A26"/>
                           </a:solidFill>
                           <a:latin typeface="BIZ UDPゴシック" pitchFamily="34" charset="0"/>
                           <a:ea typeface="BIZ UDPゴシック" pitchFamily="34" charset="-122"/>
@@ -42538,7 +42538,7 @@
                       <a:tailEnd type="none" w="med" len="med"/>
                     </a:lnB>
                     <a:solidFill>
-                      <a:srgbClr val="FCEBE6"/>
+                      <a:srgbClr val="DDE7EF"/>
                     </a:solidFill>
                   </a:tcPr>
                 </a:tc>
@@ -42553,7 +42553,7 @@
                       <a:r>
                         <a:rPr lang="en-US" sz="1800" b="1" dirty="0">
                           <a:solidFill>
-                            <a:srgbClr val="A3402C"/>
+                            <a:srgbClr val="1E2A26"/>
                           </a:solidFill>
                           <a:latin typeface="BIZ UDPゴシック" pitchFamily="34" charset="0"/>
                           <a:ea typeface="BIZ UDPゴシック" pitchFamily="34" charset="-122"/>
@@ -42606,7 +42606,7 @@
                       <a:tailEnd type="none" w="med" len="med"/>
                     </a:lnB>
                     <a:solidFill>
-                      <a:srgbClr val="FCEBE6"/>
+                      <a:srgbClr val="DDE7EF"/>
                     </a:solidFill>
                   </a:tcPr>
                 </a:tc>
@@ -42621,7 +42621,7 @@
                       <a:r>
                         <a:rPr lang="en-US" sz="1800" b="1" dirty="0">
                           <a:solidFill>
-                            <a:srgbClr val="A3402C"/>
+                            <a:srgbClr val="1E2A26"/>
                           </a:solidFill>
                           <a:latin typeface="BIZ UDPゴシック" pitchFamily="34" charset="0"/>
                           <a:ea typeface="BIZ UDPゴシック" pitchFamily="34" charset="-122"/>
@@ -42674,7 +42674,7 @@
                       <a:tailEnd type="none" w="med" len="med"/>
                     </a:lnB>
                     <a:solidFill>
-                      <a:srgbClr val="FCEBE6"/>
+                      <a:srgbClr val="DDE7EF"/>
                     </a:solidFill>
                   </a:tcPr>
                 </a:tc>
@@ -42759,7 +42759,7 @@
                       <a:r>
                         <a:rPr lang="en-US" sz="1800" b="1" dirty="0">
                           <a:solidFill>
-                            <a:srgbClr val="A3402C"/>
+                            <a:srgbClr val="1E2A26"/>
                           </a:solidFill>
                           <a:latin typeface="BIZ UDPゴシック" pitchFamily="34" charset="0"/>
                           <a:ea typeface="BIZ UDPゴシック" pitchFamily="34" charset="-122"/>
@@ -42812,7 +42812,7 @@
                       <a:tailEnd type="none" w="med" len="med"/>
                     </a:lnB>
                     <a:solidFill>
-                      <a:srgbClr val="FCEBE6"/>
+                      <a:srgbClr val="DDE7EF"/>
                     </a:solidFill>
                   </a:tcPr>
                 </a:tc>
@@ -42827,7 +42827,7 @@
                       <a:r>
                         <a:rPr lang="en-US" sz="1800" b="1" dirty="0">
                           <a:solidFill>
-                            <a:srgbClr val="A3402C"/>
+                            <a:srgbClr val="1E2A26"/>
                           </a:solidFill>
                           <a:latin typeface="BIZ UDPゴシック" pitchFamily="34" charset="0"/>
                           <a:ea typeface="BIZ UDPゴシック" pitchFamily="34" charset="-122"/>
@@ -42880,7 +42880,7 @@
                       <a:tailEnd type="none" w="med" len="med"/>
                     </a:lnB>
                     <a:solidFill>
-                      <a:srgbClr val="FCEBE6"/>
+                      <a:srgbClr val="DDE7EF"/>
                     </a:solidFill>
                   </a:tcPr>
                 </a:tc>
@@ -42895,7 +42895,7 @@
                       <a:r>
                         <a:rPr lang="en-US" sz="1800" b="1" dirty="0">
                           <a:solidFill>
-                            <a:srgbClr val="A3402C"/>
+                            <a:srgbClr val="1E2A26"/>
                           </a:solidFill>
                           <a:latin typeface="BIZ UDPゴシック" pitchFamily="34" charset="0"/>
                           <a:ea typeface="BIZ UDPゴシック" pitchFamily="34" charset="-122"/>
@@ -42948,7 +42948,7 @@
                       <a:tailEnd type="none" w="med" len="med"/>
                     </a:lnB>
                     <a:solidFill>
-                      <a:srgbClr val="FCEBE6"/>
+                      <a:srgbClr val="DDE7EF"/>
                     </a:solidFill>
                   </a:tcPr>
                 </a:tc>
@@ -42963,7 +42963,7 @@
                       <a:r>
                         <a:rPr lang="en-US" sz="1800" b="1" dirty="0">
                           <a:solidFill>
-                            <a:srgbClr val="A3402C"/>
+                            <a:srgbClr val="1E2A26"/>
                           </a:solidFill>
                           <a:latin typeface="BIZ UDPゴシック" pitchFamily="34" charset="0"/>
                           <a:ea typeface="BIZ UDPゴシック" pitchFamily="34" charset="-122"/>
@@ -43016,7 +43016,7 @@
                       <a:tailEnd type="none" w="med" len="med"/>
                     </a:lnB>
                     <a:solidFill>
-                      <a:srgbClr val="FCEBE6"/>
+                      <a:srgbClr val="DDE7EF"/>
                     </a:solidFill>
                   </a:tcPr>
                 </a:tc>
@@ -43031,7 +43031,7 @@
                       <a:r>
                         <a:rPr lang="en-US" sz="1800" b="1" dirty="0">
                           <a:solidFill>
-                            <a:srgbClr val="A3402C"/>
+                            <a:srgbClr val="1E2A26"/>
                           </a:solidFill>
                           <a:latin typeface="BIZ UDPゴシック" pitchFamily="34" charset="0"/>
                           <a:ea typeface="BIZ UDPゴシック" pitchFamily="34" charset="-122"/>
@@ -43084,7 +43084,7 @@
                       <a:tailEnd type="none" w="med" len="med"/>
                     </a:lnB>
                     <a:solidFill>
-                      <a:srgbClr val="FCEBE6"/>
+                      <a:srgbClr val="DDE7EF"/>
                     </a:solidFill>
                   </a:tcPr>
                 </a:tc>
@@ -43099,7 +43099,7 @@
                       <a:r>
                         <a:rPr lang="en-US" sz="1800" b="1" dirty="0">
                           <a:solidFill>
-                            <a:srgbClr val="A3402C"/>
+                            <a:srgbClr val="1E2A26"/>
                           </a:solidFill>
                           <a:latin typeface="BIZ UDPゴシック" pitchFamily="34" charset="0"/>
                           <a:ea typeface="BIZ UDPゴシック" pitchFamily="34" charset="-122"/>
@@ -43152,7 +43152,7 @@
                       <a:tailEnd type="none" w="med" len="med"/>
                     </a:lnB>
                     <a:solidFill>
-                      <a:srgbClr val="FCEBE6"/>
+                      <a:srgbClr val="DDE7EF"/>
                     </a:solidFill>
                   </a:tcPr>
                 </a:tc>
@@ -43167,7 +43167,7 @@
                       <a:r>
                         <a:rPr lang="en-US" sz="1800" b="1" dirty="0">
                           <a:solidFill>
-                            <a:srgbClr val="A3402C"/>
+                            <a:srgbClr val="1E2A26"/>
                           </a:solidFill>
                           <a:latin typeface="BIZ UDPゴシック" pitchFamily="34" charset="0"/>
                           <a:ea typeface="BIZ UDPゴシック" pitchFamily="34" charset="-122"/>
@@ -43220,7 +43220,7 @@
                       <a:tailEnd type="none" w="med" len="med"/>
                     </a:lnB>
                     <a:solidFill>
-                      <a:srgbClr val="FCEBE6"/>
+                      <a:srgbClr val="DDE7EF"/>
                     </a:solidFill>
                   </a:tcPr>
                 </a:tc>
@@ -43305,7 +43305,7 @@
                       <a:r>
                         <a:rPr lang="en-US" sz="1800" b="1" dirty="0">
                           <a:solidFill>
-                            <a:srgbClr val="A3402C"/>
+                            <a:srgbClr val="1E2A26"/>
                           </a:solidFill>
                           <a:latin typeface="BIZ UDPゴシック" pitchFamily="34" charset="0"/>
                           <a:ea typeface="BIZ UDPゴシック" pitchFamily="34" charset="-122"/>
@@ -43358,7 +43358,7 @@
                       <a:tailEnd type="none" w="med" len="med"/>
                     </a:lnB>
                     <a:solidFill>
-                      <a:srgbClr val="FCEBE6"/>
+                      <a:srgbClr val="DDE7EF"/>
                     </a:solidFill>
                   </a:tcPr>
                 </a:tc>
@@ -43373,7 +43373,7 @@
                       <a:r>
                         <a:rPr lang="en-US" sz="1800" b="1" dirty="0">
                           <a:solidFill>
-                            <a:srgbClr val="A3402C"/>
+                            <a:srgbClr val="1E2A26"/>
                           </a:solidFill>
                           <a:latin typeface="BIZ UDPゴシック" pitchFamily="34" charset="0"/>
                           <a:ea typeface="BIZ UDPゴシック" pitchFamily="34" charset="-122"/>
@@ -43426,7 +43426,7 @@
                       <a:tailEnd type="none" w="med" len="med"/>
                     </a:lnB>
                     <a:solidFill>
-                      <a:srgbClr val="FCEBE6"/>
+                      <a:srgbClr val="DDE7EF"/>
                     </a:solidFill>
                   </a:tcPr>
                 </a:tc>
@@ -43441,7 +43441,7 @@
                       <a:r>
                         <a:rPr lang="en-US" sz="1800" b="1" dirty="0">
                           <a:solidFill>
-                            <a:srgbClr val="A3402C"/>
+                            <a:srgbClr val="1E2A26"/>
                           </a:solidFill>
                           <a:latin typeface="BIZ UDPゴシック" pitchFamily="34" charset="0"/>
                           <a:ea typeface="BIZ UDPゴシック" pitchFamily="34" charset="-122"/>
@@ -43494,7 +43494,7 @@
                       <a:tailEnd type="none" w="med" len="med"/>
                     </a:lnB>
                     <a:solidFill>
-                      <a:srgbClr val="FCEBE6"/>
+                      <a:srgbClr val="DDE7EF"/>
                     </a:solidFill>
                   </a:tcPr>
                 </a:tc>
@@ -43509,7 +43509,7 @@
                       <a:r>
                         <a:rPr lang="en-US" sz="1800" b="1" dirty="0">
                           <a:solidFill>
-                            <a:srgbClr val="A3402C"/>
+                            <a:srgbClr val="1E2A26"/>
                           </a:solidFill>
                           <a:latin typeface="BIZ UDPゴシック" pitchFamily="34" charset="0"/>
                           <a:ea typeface="BIZ UDPゴシック" pitchFamily="34" charset="-122"/>
@@ -43562,7 +43562,7 @@
                       <a:tailEnd type="none" w="med" len="med"/>
                     </a:lnB>
                     <a:solidFill>
-                      <a:srgbClr val="FCEBE6"/>
+                      <a:srgbClr val="DDE7EF"/>
                     </a:solidFill>
                   </a:tcPr>
                 </a:tc>
@@ -43577,7 +43577,7 @@
                       <a:r>
                         <a:rPr lang="en-US" sz="1800" b="1" dirty="0">
                           <a:solidFill>
-                            <a:srgbClr val="A3402C"/>
+                            <a:srgbClr val="1E2A26"/>
                           </a:solidFill>
                           <a:latin typeface="BIZ UDPゴシック" pitchFamily="34" charset="0"/>
                           <a:ea typeface="BIZ UDPゴシック" pitchFamily="34" charset="-122"/>
@@ -43630,7 +43630,7 @@
                       <a:tailEnd type="none" w="med" len="med"/>
                     </a:lnB>
                     <a:solidFill>
-                      <a:srgbClr val="FCEBE6"/>
+                      <a:srgbClr val="DDE7EF"/>
                     </a:solidFill>
                   </a:tcPr>
                 </a:tc>
@@ -43645,7 +43645,7 @@
                       <a:r>
                         <a:rPr lang="en-US" sz="1800" b="1" dirty="0">
                           <a:solidFill>
-                            <a:srgbClr val="A3402C"/>
+                            <a:srgbClr val="1E2A26"/>
                           </a:solidFill>
                           <a:latin typeface="BIZ UDPゴシック" pitchFamily="34" charset="0"/>
                           <a:ea typeface="BIZ UDPゴシック" pitchFamily="34" charset="-122"/>
@@ -43698,7 +43698,7 @@
                       <a:tailEnd type="none" w="med" len="med"/>
                     </a:lnB>
                     <a:solidFill>
-                      <a:srgbClr val="FCEBE6"/>
+                      <a:srgbClr val="DDE7EF"/>
                     </a:solidFill>
                   </a:tcPr>
                 </a:tc>
@@ -43713,7 +43713,7 @@
                       <a:r>
                         <a:rPr lang="en-US" sz="1800" b="1" dirty="0">
                           <a:solidFill>
-                            <a:srgbClr val="A3402C"/>
+                            <a:srgbClr val="1E2A26"/>
                           </a:solidFill>
                           <a:latin typeface="BIZ UDPゴシック" pitchFamily="34" charset="0"/>
                           <a:ea typeface="BIZ UDPゴシック" pitchFamily="34" charset="-122"/>
@@ -43766,7 +43766,7 @@
                       <a:tailEnd type="none" w="med" len="med"/>
                     </a:lnB>
                     <a:solidFill>
-                      <a:srgbClr val="FCEBE6"/>
+                      <a:srgbClr val="DDE7EF"/>
                     </a:solidFill>
                   </a:tcPr>
                 </a:tc>
@@ -43851,7 +43851,7 @@
                       <a:r>
                         <a:rPr lang="en-US" sz="1800" b="1" dirty="0">
                           <a:solidFill>
-                            <a:srgbClr val="A3402C"/>
+                            <a:srgbClr val="1E2A26"/>
                           </a:solidFill>
                           <a:latin typeface="BIZ UDPゴシック" pitchFamily="34" charset="0"/>
                           <a:ea typeface="BIZ UDPゴシック" pitchFamily="34" charset="-122"/>
@@ -43904,7 +43904,7 @@
                       <a:tailEnd type="none" w="med" len="med"/>
                     </a:lnB>
                     <a:solidFill>
-                      <a:srgbClr val="FCEBE6"/>
+                      <a:srgbClr val="DDE7EF"/>
                     </a:solidFill>
                   </a:tcPr>
                 </a:tc>
@@ -43919,7 +43919,7 @@
                       <a:r>
                         <a:rPr lang="en-US" sz="1800" b="1" dirty="0">
                           <a:solidFill>
-                            <a:srgbClr val="A3402C"/>
+                            <a:srgbClr val="1E2A26"/>
                           </a:solidFill>
                           <a:latin typeface="BIZ UDPゴシック" pitchFamily="34" charset="0"/>
                           <a:ea typeface="BIZ UDPゴシック" pitchFamily="34" charset="-122"/>
@@ -43972,7 +43972,7 @@
                       <a:tailEnd type="none" w="med" len="med"/>
                     </a:lnB>
                     <a:solidFill>
-                      <a:srgbClr val="FCEBE6"/>
+                      <a:srgbClr val="DDE7EF"/>
                     </a:solidFill>
                   </a:tcPr>
                 </a:tc>
@@ -43987,7 +43987,7 @@
                       <a:r>
                         <a:rPr lang="en-US" sz="1800" b="1" dirty="0">
                           <a:solidFill>
-                            <a:srgbClr val="A3402C"/>
+                            <a:srgbClr val="1E2A26"/>
                           </a:solidFill>
                           <a:latin typeface="BIZ UDPゴシック" pitchFamily="34" charset="0"/>
                           <a:ea typeface="BIZ UDPゴシック" pitchFamily="34" charset="-122"/>
@@ -44040,7 +44040,7 @@
                       <a:tailEnd type="none" w="med" len="med"/>
                     </a:lnB>
                     <a:solidFill>
-                      <a:srgbClr val="FCEBE6"/>
+                      <a:srgbClr val="DDE7EF"/>
                     </a:solidFill>
                   </a:tcPr>
                 </a:tc>
@@ -44055,7 +44055,7 @@
                       <a:r>
                         <a:rPr lang="en-US" sz="1800" b="1" dirty="0">
                           <a:solidFill>
-                            <a:srgbClr val="A3402C"/>
+                            <a:srgbClr val="1E2A26"/>
                           </a:solidFill>
                           <a:latin typeface="BIZ UDPゴシック" pitchFamily="34" charset="0"/>
                           <a:ea typeface="BIZ UDPゴシック" pitchFamily="34" charset="-122"/>
@@ -44108,7 +44108,7 @@
                       <a:tailEnd type="none" w="med" len="med"/>
                     </a:lnB>
                     <a:solidFill>
-                      <a:srgbClr val="FCEBE6"/>
+                      <a:srgbClr val="DDE7EF"/>
                     </a:solidFill>
                   </a:tcPr>
                 </a:tc>
@@ -44123,7 +44123,7 @@
                       <a:r>
                         <a:rPr lang="en-US" sz="1800" b="1" dirty="0">
                           <a:solidFill>
-                            <a:srgbClr val="A3402C"/>
+                            <a:srgbClr val="1E2A26"/>
                           </a:solidFill>
                           <a:latin typeface="BIZ UDPゴシック" pitchFamily="34" charset="0"/>
                           <a:ea typeface="BIZ UDPゴシック" pitchFamily="34" charset="-122"/>
@@ -44176,7 +44176,7 @@
                       <a:tailEnd type="none" w="med" len="med"/>
                     </a:lnB>
                     <a:solidFill>
-                      <a:srgbClr val="FCEBE6"/>
+                      <a:srgbClr val="DDE7EF"/>
                     </a:solidFill>
                   </a:tcPr>
                 </a:tc>
@@ -44191,7 +44191,7 @@
                       <a:r>
                         <a:rPr lang="en-US" sz="1800" b="1" dirty="0">
                           <a:solidFill>
-                            <a:srgbClr val="A3402C"/>
+                            <a:srgbClr val="1E2A26"/>
                           </a:solidFill>
                           <a:latin typeface="BIZ UDPゴシック" pitchFamily="34" charset="0"/>
                           <a:ea typeface="BIZ UDPゴシック" pitchFamily="34" charset="-122"/>
@@ -44244,7 +44244,7 @@
                       <a:tailEnd type="none" w="med" len="med"/>
                     </a:lnB>
                     <a:solidFill>
-                      <a:srgbClr val="FCEBE6"/>
+                      <a:srgbClr val="DDE7EF"/>
                     </a:solidFill>
                   </a:tcPr>
                 </a:tc>
@@ -44259,7 +44259,7 @@
                       <a:r>
                         <a:rPr lang="en-US" sz="1800" b="1" dirty="0">
                           <a:solidFill>
-                            <a:srgbClr val="A3402C"/>
+                            <a:srgbClr val="1E2A26"/>
                           </a:solidFill>
                           <a:latin typeface="BIZ UDPゴシック" pitchFamily="34" charset="0"/>
                           <a:ea typeface="BIZ UDPゴシック" pitchFamily="34" charset="-122"/>
@@ -44312,7 +44312,7 @@
                       <a:tailEnd type="none" w="med" len="med"/>
                     </a:lnB>
                     <a:solidFill>
-                      <a:srgbClr val="FCEBE6"/>
+                      <a:srgbClr val="DDE7EF"/>
                     </a:solidFill>
                   </a:tcPr>
                 </a:tc>
@@ -44882,7 +44882,7 @@
             <a:avLst/>
           </a:prstGeom>
           <a:solidFill>
-            <a:srgbClr val="FCEBE6"/>
+            <a:srgbClr val="DDE7EF"/>
           </a:solidFill>
           <a:ln w="12700">
             <a:solidFill>
@@ -48911,8 +48911,8 @@
         </p:nvSpPr>
         <p:spPr>
           <a:xfrm>
-            <a:off x="8412480" y="3840480"/>
-            <a:ext cx="3017520" cy="914400"/>
+            <a:off x="8412480" y="3794760"/>
+            <a:ext cx="3017520" cy="777240"/>
           </a:xfrm>
           <a:prstGeom prst="rect">
             <a:avLst/>
@@ -48936,7 +48936,7 @@
                 <a:ea typeface="BIZ UDPゴシック" pitchFamily="34" charset="-122"/>
                 <a:cs typeface="BIZ UDPゴシック" pitchFamily="34" charset="-120"/>
               </a:rPr>
-              <a:t>小学校だけでなく、地区全体の教育環境を考える</a:t>
+              <a:t>若穂中は、3つの中学校が一つになってできた学校</a:t>
             </a:r>
             <a:endParaRPr lang="en-US" sz="1700" dirty="0"/>
           </a:p>
@@ -48950,8 +48950,8 @@
         </p:nvSpPr>
         <p:spPr>
           <a:xfrm>
-            <a:off x="8412480" y="4800600"/>
-            <a:ext cx="3017520" cy="822960"/>
+            <a:off x="8412480" y="4617720"/>
+            <a:ext cx="3017520" cy="1051560"/>
           </a:xfrm>
           <a:prstGeom prst="rect">
             <a:avLst/>
@@ -48975,7 +48975,7 @@
                 <a:ea typeface="BIZ UDPゴシック" pitchFamily="34" charset="-122"/>
                 <a:cs typeface="BIZ UDPゴシック" pitchFamily="34" charset="-120"/>
               </a:rPr>
-              <a:t>小中9年間の学びの連続性も、検討する価値のある視点です。</a:t>
+              <a:t>昭和36〜37年（1961〜62年）に統合。部活動など、中学校の環境も合わせて考えます。</a:t>
             </a:r>
             <a:endParaRPr lang="en-US" sz="1500" dirty="0"/>
           </a:p>
@@ -49014,7 +49014,7 @@
                 <a:ea typeface="BIZ UDPゴシック" pitchFamily="34" charset="-122"/>
                 <a:cs typeface="BIZ UDPゴシック" pitchFamily="34" charset="-120"/>
               </a:rPr>
-              <a:t>出典：提供資料「生徒数推計」（R8.5.1現在）。</a:t>
+              <a:t>出典：提供資料「生徒数推計」（R8.5.1現在）。若穂中の成り立ちの出典は［確認中］。</a:t>
             </a:r>
             <a:endParaRPr lang="en-US" sz="1200" dirty="0"/>
           </a:p>
@@ -49586,7 +49586,7 @@
             <a:r>
               <a:rPr lang="en-US" sz="3600" b="1" dirty="0">
                 <a:solidFill>
-                  <a:srgbClr val="9AA59F"/>
+                  <a:srgbClr val="56635D"/>
                 </a:solidFill>
                 <a:latin typeface="BIZ UDPゴシック" pitchFamily="34" charset="0"/>
                 <a:ea typeface="BIZ UDPゴシック" pitchFamily="34" charset="-122"/>

</xml_diff>

<commit_message>
Remove wording that presupposes consolidation
Cover tagline, closing line, and several headings no longer imply that the
number of schools will be reduced; add the rule to CLAUDE.md.

Co-Authored-By: Claude Opus 5.5 <noreply@anthropic.com>
Claude-Session: https://claude.ai/code/session_01W71YS9cuG6jLhNCgQT7KJE
</commit_message>
<xml_diff>
--- a/output/若穂地区_住民説明会資料.pptx
+++ b/output/若穂地区_住民説明会資料.pptx
@@ -5142,7 +5142,7 @@
                 <a:ea typeface="BIZ UDPゴシック" pitchFamily="34" charset="-122"/>
                 <a:cs typeface="BIZ UDPゴシック" pitchFamily="34" charset="-120"/>
               </a:rPr>
-              <a:t>学校の数を決める前に、どんな学びを残したいか。</a:t>
+              <a:t>結論の前に、子どもたちにどんな学びを残したいか。</a:t>
             </a:r>
             <a:endParaRPr lang="en-US" sz="2800" dirty="0"/>
           </a:p>
@@ -20949,7 +20949,7 @@
                 <a:ea typeface="BIZ UDPゴシック" pitchFamily="34" charset="-122"/>
                 <a:cs typeface="BIZ UDPゴシック" pitchFamily="34" charset="-120"/>
               </a:rPr>
-              <a:t>現状維持から再編まで</a:t>
+              <a:t>今の形を続ける案も含めて</a:t>
             </a:r>
             <a:endParaRPr lang="en-US" sz="1600" dirty="0"/>
           </a:p>
@@ -23243,7 +23243,7 @@
                 <a:ea typeface="BIZ UDPゴシック" pitchFamily="34" charset="-122"/>
                 <a:cs typeface="BIZ UDPゴシック" pitchFamily="34" charset="-120"/>
               </a:rPr>
-              <a:t>再編で使わなくなる校舎が出る場合は、避難所の機能をどう保つかを、地域と一緒に考える必要があります。</a:t>
+              <a:t>どの選択肢でも、学校が地域の避難所として役割を果たせるかを、比べる視点に入れます。</a:t>
             </a:r>
             <a:endParaRPr lang="en-US" sz="1800" dirty="0"/>
           </a:p>
@@ -23429,7 +23429,7 @@
                   <a:srgbClr val="1D4636"/>
                 </a:solidFill>
               </a:rPr>
-              <a:t>再編を考えるなら、生活への影響も見える化する</a:t>
+              <a:t>どの選択肢でも、生活への影響を見える化する</a:t>
             </a:r>
             <a:endParaRPr lang="en-US" sz="3000" dirty="0"/>
           </a:p>
@@ -24826,7 +24826,7 @@
                 <a:ea typeface="BIZ UDPゴシック" pitchFamily="34" charset="-122"/>
                 <a:cs typeface="BIZ UDPゴシック" pitchFamily="34" charset="-120"/>
               </a:rPr>
-              <a:t>再編の結論を待たずに、3校と中学校で試せること</a:t>
+              <a:t>結論を待たずに、3校と中学校で試せること</a:t>
             </a:r>
             <a:endParaRPr lang="en-US" sz="1600" dirty="0"/>
           </a:p>
@@ -29666,7 +29666,7 @@
                 <a:ea typeface="BIZ UDPゴシック" pitchFamily="34" charset="-122"/>
                 <a:cs typeface="BIZ UDPゴシック" pitchFamily="34" charset="-120"/>
               </a:rPr>
-              <a:t>学校の数を減らすことではなく、未来の学びをつくること。</a:t>
+              <a:t>目指すのは、子どもたちの未来の学びをつくること。</a:t>
             </a:r>
             <a:endParaRPr lang="en-US" sz="2600" dirty="0"/>
           </a:p>
@@ -34855,7 +34855,7 @@
                   <a:srgbClr val="1D4636"/>
                 </a:solidFill>
               </a:rPr>
-              <a:t>検討の出発点｜誰のための学校再編か</a:t>
+              <a:t>検討の出発点｜誰のための検討か</a:t>
             </a:r>
             <a:endParaRPr lang="en-US" sz="3000" dirty="0"/>
           </a:p>
@@ -45311,7 +45311,7 @@
                 <a:ea typeface="BIZ UDPゴシック" pitchFamily="34" charset="-122"/>
                 <a:cs typeface="BIZ UDPゴシック" pitchFamily="34" charset="-120"/>
               </a:rPr>
-              <a:t>学校の配置や仕組みを見直すこと。統合や通学区域の変更なども含みます。</a:t>
+              <a:t>学校の配置や仕組みを見直すこと。今の形を続けることも含めて検討します。</a:t>
             </a:r>
             <a:endParaRPr lang="en-US" sz="1600" dirty="0"/>
           </a:p>

</xml_diff>

<commit_message>
Describe facility timings as 'eligible from' rather than scheduled work
Co-Authored-By: Claude Opus 5.5 <noreply@anthropic.com>
Claude-Session: https://claude.ai/code/session_01W71YS9cuG6jLhNCgQT7KJE
</commit_message>
<xml_diff>
--- a/output/若穂地区_住民説明会資料.pptx
+++ b/output/若穂地区_住民説明会資料.pptx
@@ -8326,7 +8326,7 @@
                 <a:ea typeface="BIZ UDPゴシック" pitchFamily="34" charset="-122"/>
                 <a:cs typeface="BIZ UDPゴシック" pitchFamily="34" charset="-120"/>
               </a:rPr>
-              <a:t>4校すべてが2030年度までに計画上の更新・改修時期を迎える（実施状況は市に確認中）</a:t>
+              <a:t>4校すべてが2030年度までに、計画上の更新・改修の対象に入る（実施状況は市に確認中）</a:t>
             </a:r>
             <a:endParaRPr lang="en-US" sz="1500" dirty="0"/>
           </a:p>
@@ -8800,7 +8800,7 @@
                 <a:ea typeface="BIZ UDPゴシック" pitchFamily="34" charset="-122"/>
                 <a:cs typeface="BIZ UDPゴシック" pitchFamily="34" charset="-120"/>
               </a:rPr>
-              <a:t>建築年度と、計画上の更新・改修時期（長寿命化計画＝建物を計画的に改修して長く使うための市の計画）</a:t>
+              <a:t>建築年度と、計画上で更新・改修の対象に入る時期（長寿命化計画＝建物を計画的に改修して長く使うための市の計画）</a:t>
             </a:r>
             <a:endParaRPr lang="en-US" sz="1600" dirty="0"/>
           </a:p>
@@ -9474,8 +9474,8 @@
         </p:nvSpPr>
         <p:spPr>
           <a:xfrm>
-            <a:off x="7443919" y="2377440"/>
-            <a:ext cx="2377440" cy="274320"/>
+            <a:off x="6712399" y="2377440"/>
+            <a:ext cx="3108960" cy="274320"/>
           </a:xfrm>
           <a:prstGeom prst="rect">
             <a:avLst/>
@@ -9499,7 +9499,7 @@
                 <a:ea typeface="BIZ UDPゴシック" pitchFamily="34" charset="-122"/>
                 <a:cs typeface="BIZ UDPゴシック" pitchFamily="34" charset="-120"/>
               </a:rPr>
-              <a:t>2023年度（R5）更新</a:t>
+              <a:t>2023年度（R5）から更新の対象</a:t>
             </a:r>
             <a:endParaRPr lang="en-US" sz="1300" dirty="0"/>
           </a:p>
@@ -9677,8 +9677,8 @@
         </p:nvSpPr>
         <p:spPr>
           <a:xfrm>
-            <a:off x="8408963" y="3246120"/>
-            <a:ext cx="2377440" cy="274320"/>
+            <a:off x="7677443" y="3246120"/>
+            <a:ext cx="3108960" cy="274320"/>
           </a:xfrm>
           <a:prstGeom prst="rect">
             <a:avLst/>
@@ -9702,7 +9702,7 @@
                 <a:ea typeface="BIZ UDPゴシック" pitchFamily="34" charset="-122"/>
                 <a:cs typeface="BIZ UDPゴシック" pitchFamily="34" charset="-120"/>
               </a:rPr>
-              <a:t>2030年度（R12）更新</a:t>
+              <a:t>2030年度（R12）から更新の対象</a:t>
             </a:r>
             <a:endParaRPr lang="en-US" sz="1300" dirty="0"/>
           </a:p>
@@ -9880,8 +9880,8 @@
         </p:nvSpPr>
         <p:spPr>
           <a:xfrm>
-            <a:off x="7995373" y="4114800"/>
-            <a:ext cx="2377440" cy="274320"/>
+            <a:off x="7263853" y="4114800"/>
+            <a:ext cx="3108960" cy="274320"/>
           </a:xfrm>
           <a:prstGeom prst="rect">
             <a:avLst/>
@@ -9905,7 +9905,7 @@
                 <a:ea typeface="BIZ UDPゴシック" pitchFamily="34" charset="-122"/>
                 <a:cs typeface="BIZ UDPゴシック" pitchFamily="34" charset="-120"/>
               </a:rPr>
-              <a:t>2027年度（R9）改修</a:t>
+              <a:t>2027年度（R9）から改修の対象</a:t>
             </a:r>
             <a:endParaRPr lang="en-US" sz="1300" dirty="0"/>
           </a:p>
@@ -10083,8 +10083,8 @@
         </p:nvSpPr>
         <p:spPr>
           <a:xfrm>
-            <a:off x="8408963" y="4983480"/>
-            <a:ext cx="2377440" cy="274320"/>
+            <a:off x="7677443" y="4983480"/>
+            <a:ext cx="3108960" cy="274320"/>
           </a:xfrm>
           <a:prstGeom prst="rect">
             <a:avLst/>
@@ -10108,7 +10108,7 @@
                 <a:ea typeface="BIZ UDPゴシック" pitchFamily="34" charset="-122"/>
                 <a:cs typeface="BIZ UDPゴシック" pitchFamily="34" charset="-120"/>
               </a:rPr>
-              <a:t>2030年度（R12）改修</a:t>
+              <a:t>2030年度（R12）から改修の対象</a:t>
             </a:r>
             <a:endParaRPr lang="en-US" sz="1300" dirty="0"/>
           </a:p>
@@ -10147,7 +10147,7 @@
                 <a:ea typeface="BIZ UDPゴシック" pitchFamily="34" charset="-122"/>
                 <a:cs typeface="BIZ UDPゴシック" pitchFamily="34" charset="-120"/>
               </a:rPr>
-              <a:t>◆計画上の時期（添付資料、令和2年4月時点）。改訂版（令和5年6月）では若穂中の6棟はすべて「長寿命化に適する」判定。</a:t>
+              <a:t>◆更新・改修の対象に入る時期の目安で、工事が決まったものではありません（添付資料、令和2年4月時点）。</a:t>
             </a:r>
             <a:endParaRPr lang="en-US" sz="1200" dirty="0"/>
           </a:p>
@@ -10164,7 +10164,7 @@
                 <a:ea typeface="BIZ UDPゴシック" pitchFamily="34" charset="-122"/>
                 <a:cs typeface="BIZ UDPゴシック" pitchFamily="34" charset="-120"/>
               </a:rPr>
-              <a:t>工事する建物と時期は随時決めるとされています。小学校3校の最新の判定と工事状況は［市に確認中］。</a:t>
+              <a:t>改訂版（令和5年6月）では若穂中の6棟すべてが「長寿命化に適する」判定。工事の建物と時期は随時決定。小学校3校は［市に確認中］。</a:t>
             </a:r>
             <a:endParaRPr lang="en-US" sz="1200" dirty="0"/>
           </a:p>

</xml_diff>